<commit_message>
feat: 탭 UI 및 스냅 캡처 기능 추가 - network.py, ui_components.py, Com_main.py로 모듈화 - 탭 인터페이스 추가 (Scan, Manual/LED, Preview & Settings) - 스냅 캡처 구현 (5MP + 3MP 순차 촬영) - captures/ 폴더에 이미지 자동 저장 - IR-CUT Day/Night 모드 제어 추가 - Com_test UI 구조와 일관성 유지 Breaking changes: - 전체 UI 탭 레이아웃으로 재구성
</commit_message>
<xml_diff>
--- a/Docs/광무선 전력 전송을 위한 Pan-Tilt 카메라 스캔 시스템에서 다중 객체 추적기법.pptx
+++ b/Docs/광무선 전력 전송을 위한 Pan-Tilt 카메라 스캔 시스템에서 다중 객체 추적기법.pptx
@@ -5,7 +5,7 @@
     <p:sldMasterId id="2147483648" r:id="rId1"/>
   </p:sldMasterIdLst>
   <p:notesMasterIdLst>
-    <p:notesMasterId r:id="rId14"/>
+    <p:notesMasterId r:id="rId15"/>
   </p:notesMasterIdLst>
   <p:sldIdLst>
     <p:sldId id="279" r:id="rId2"/>
@@ -16,10 +16,11 @@
     <p:sldId id="304" r:id="rId7"/>
     <p:sldId id="315" r:id="rId8"/>
     <p:sldId id="316" r:id="rId9"/>
-    <p:sldId id="306" r:id="rId10"/>
-    <p:sldId id="307" r:id="rId11"/>
-    <p:sldId id="308" r:id="rId12"/>
-    <p:sldId id="305" r:id="rId13"/>
+    <p:sldId id="317" r:id="rId10"/>
+    <p:sldId id="306" r:id="rId11"/>
+    <p:sldId id="307" r:id="rId12"/>
+    <p:sldId id="308" r:id="rId13"/>
+    <p:sldId id="305" r:id="rId14"/>
   </p:sldIdLst>
   <p:sldSz cx="12192000" cy="6858000"/>
   <p:notesSz cx="6858000" cy="9144000"/>
@@ -135,6 +136,7 @@
             <p14:sldId id="304"/>
             <p14:sldId id="315"/>
             <p14:sldId id="316"/>
+            <p14:sldId id="317"/>
             <p14:sldId id="306"/>
             <p14:sldId id="307"/>
             <p14:sldId id="308"/>
@@ -241,7 +243,7 @@
               <a:pPr lvl="0">
                 <a:defRPr/>
               </a:pPr>
-              <a:t>2026-01-28</a:t>
+              <a:t>2026-01-29</a:t>
             </a:fld>
             <a:endParaRPr lang="ko-KR" altLang="en-US"/>
           </a:p>
@@ -679,6 +681,282 @@
         <p:cNvPr id="1" name="">
           <a:extLst>
             <a:ext uri="{FF2B5EF4-FFF2-40B4-BE49-F238E27FC236}">
+              <a16:creationId xmlns:a16="http://schemas.microsoft.com/office/drawing/2014/main" id="{5853F38A-D6A8-AB8C-619F-F7CAFAE0189C}"/>
+            </a:ext>
+          </a:extLst>
+        </p:cNvPr>
+        <p:cNvGrpSpPr/>
+        <p:nvPr/>
+      </p:nvGrpSpPr>
+      <p:grpSpPr>
+        <a:xfrm>
+          <a:off x="0" y="0"/>
+          <a:ext cx="0" cy="0"/>
+          <a:chOff x="0" y="0"/>
+          <a:chExt cx="0" cy="0"/>
+        </a:xfrm>
+      </p:grpSpPr>
+      <p:sp>
+        <p:nvSpPr>
+          <p:cNvPr id="2" name="슬라이드 이미지 개체 틀 1">
+            <a:extLst>
+              <a:ext uri="{FF2B5EF4-FFF2-40B4-BE49-F238E27FC236}">
+                <a16:creationId xmlns:a16="http://schemas.microsoft.com/office/drawing/2014/main" id="{A1ADCCB8-0F65-304F-3DF1-8BECCA8C1EB9}"/>
+              </a:ext>
+            </a:extLst>
+          </p:cNvPr>
+          <p:cNvSpPr>
+            <a:spLocks noGrp="1" noRot="1" noChangeAspect="1" noTextEdit="1"/>
+          </p:cNvSpPr>
+          <p:nvPr>
+            <p:ph type="sldImg"/>
+          </p:nvPr>
+        </p:nvSpPr>
+        <p:spPr/>
+      </p:sp>
+      <p:sp>
+        <p:nvSpPr>
+          <p:cNvPr id="3" name="슬라이드 노트 개체 틀 2">
+            <a:extLst>
+              <a:ext uri="{FF2B5EF4-FFF2-40B4-BE49-F238E27FC236}">
+                <a16:creationId xmlns:a16="http://schemas.microsoft.com/office/drawing/2014/main" id="{EF53B96C-B14F-7EA6-75AA-2F6BED3B0597}"/>
+              </a:ext>
+            </a:extLst>
+          </p:cNvPr>
+          <p:cNvSpPr>
+            <a:spLocks noGrp="1"/>
+          </p:cNvSpPr>
+          <p:nvPr>
+            <p:ph type="body" idx="1"/>
+          </p:nvPr>
+        </p:nvSpPr>
+        <p:spPr/>
+        <p:txBody>
+          <a:bodyPr/>
+          <a:lstStyle/>
+          <a:p>
+            <a:pPr lvl="0">
+              <a:defRPr/>
+            </a:pPr>
+            <a:r>
+              <a:rPr lang="ko-KR" altLang="en-US" dirty="0"/>
+              <a:t>성능 평가입니다</a:t>
+            </a:r>
+            <a:r>
+              <a:rPr lang="en-US" altLang="ko-KR" dirty="0"/>
+              <a:t>.</a:t>
+            </a:r>
+          </a:p>
+          <a:p>
+            <a:pPr lvl="0">
+              <a:defRPr/>
+            </a:pPr>
+            <a:r>
+              <a:rPr lang="ko-KR" altLang="en-US" dirty="0"/>
+              <a:t>검증결과 실내 환경에서 </a:t>
+            </a:r>
+            <a:r>
+              <a:rPr lang="en-US" altLang="ko-KR" dirty="0"/>
+              <a:t>4</a:t>
+            </a:r>
+            <a:r>
+              <a:rPr lang="ko-KR" altLang="en-US" dirty="0"/>
+              <a:t>개의 수신부를 </a:t>
+            </a:r>
+            <a:r>
+              <a:rPr lang="en-US" altLang="ko-KR" dirty="0"/>
+              <a:t>5~10m </a:t>
+            </a:r>
+            <a:r>
+              <a:rPr lang="ko-KR" altLang="en-US" dirty="0"/>
+              <a:t>거리에 배치하여 획득한 데이터셋으로 검증을 하였고</a:t>
+            </a:r>
+            <a:r>
+              <a:rPr lang="en-US" altLang="ko-KR" dirty="0"/>
+              <a:t>.</a:t>
+            </a:r>
+          </a:p>
+          <a:p>
+            <a:pPr lvl="0">
+              <a:defRPr/>
+            </a:pPr>
+            <a:r>
+              <a:rPr lang="ko-KR" altLang="en-US" dirty="0"/>
+              <a:t>결과는 표</a:t>
+            </a:r>
+            <a:r>
+              <a:rPr lang="en-US" altLang="ko-KR" dirty="0"/>
+              <a:t>1</a:t>
+            </a:r>
+            <a:r>
+              <a:rPr lang="ko-KR" altLang="en-US" dirty="0"/>
+              <a:t>과 같습니다</a:t>
+            </a:r>
+            <a:r>
+              <a:rPr lang="en-US" altLang="ko-KR" dirty="0"/>
+              <a:t>. </a:t>
+            </a:r>
+          </a:p>
+          <a:p>
+            <a:pPr lvl="0">
+              <a:defRPr/>
+            </a:pPr>
+            <a:r>
+              <a:rPr lang="ko-KR" altLang="en-US" dirty="0"/>
+              <a:t>표</a:t>
+            </a:r>
+            <a:r>
+              <a:rPr lang="en-US" altLang="ko-KR" dirty="0"/>
+              <a:t>2</a:t>
+            </a:r>
+            <a:r>
+              <a:rPr lang="ko-KR" altLang="en-US" dirty="0"/>
+              <a:t>는 타 </a:t>
+            </a:r>
+            <a:r>
+              <a:rPr lang="en-US" altLang="ko-KR" dirty="0"/>
+              <a:t>MOT </a:t>
+            </a:r>
+            <a:r>
+              <a:rPr lang="en-US" altLang="ko-KR" dirty="0" err="1"/>
+              <a:t>Mehod</a:t>
+            </a:r>
+            <a:r>
+              <a:rPr lang="ko-KR" altLang="en-US" dirty="0"/>
+              <a:t>의 </a:t>
+            </a:r>
+            <a:r>
+              <a:rPr lang="en-US" altLang="ko-KR" dirty="0"/>
+              <a:t>MOTA </a:t>
+            </a:r>
+            <a:r>
+              <a:rPr lang="ko-KR" altLang="en-US" dirty="0"/>
+              <a:t>결과인데 </a:t>
+            </a:r>
+            <a:r>
+              <a:rPr lang="en-US" altLang="ko-KR" dirty="0"/>
+              <a:t>KITTI test set </a:t>
+            </a:r>
+            <a:r>
+              <a:rPr lang="ko-KR" altLang="en-US" dirty="0" err="1"/>
+              <a:t>에대한</a:t>
+            </a:r>
+            <a:r>
+              <a:rPr lang="ko-KR" altLang="en-US" dirty="0"/>
+              <a:t> 지표입니다</a:t>
+            </a:r>
+            <a:r>
+              <a:rPr lang="en-US" altLang="ko-KR" dirty="0"/>
+              <a:t>.</a:t>
+            </a:r>
+          </a:p>
+          <a:p>
+            <a:pPr lvl="0">
+              <a:defRPr/>
+            </a:pPr>
+            <a:r>
+              <a:rPr lang="en-US" altLang="ko-KR" dirty="0"/>
+              <a:t>Kitti test set</a:t>
+            </a:r>
+            <a:r>
+              <a:rPr lang="ko-KR" altLang="en-US" dirty="0"/>
+              <a:t>은 자율주행 을 위한 데이터 셋입니다</a:t>
+            </a:r>
+            <a:r>
+              <a:rPr lang="en-US" altLang="ko-KR" dirty="0"/>
+              <a:t>.</a:t>
+            </a:r>
+          </a:p>
+          <a:p>
+            <a:pPr lvl="0">
+              <a:defRPr/>
+            </a:pPr>
+            <a:r>
+              <a:rPr lang="ko-KR" altLang="en-US" dirty="0"/>
+              <a:t>저희가 제안하는 방식은 보다 </a:t>
+            </a:r>
+            <a:r>
+              <a:rPr lang="ko-KR" altLang="en-US" dirty="0" err="1"/>
+              <a:t>쉬운환경임에따라</a:t>
+            </a:r>
+            <a:r>
+              <a:rPr lang="ko-KR" altLang="en-US" dirty="0"/>
+              <a:t> 보다 높은 </a:t>
+            </a:r>
+            <a:r>
+              <a:rPr lang="en-US" altLang="ko-KR" dirty="0"/>
+              <a:t>MOTA </a:t>
+            </a:r>
+            <a:r>
+              <a:rPr lang="ko-KR" altLang="en-US" dirty="0"/>
+              <a:t>결과를 </a:t>
+            </a:r>
+            <a:r>
+              <a:rPr lang="ko-KR" altLang="en-US" dirty="0" err="1"/>
+              <a:t>얻은것을</a:t>
+            </a:r>
+            <a:r>
+              <a:rPr lang="ko-KR" altLang="en-US" dirty="0"/>
+              <a:t> 확인할 수 있습니다</a:t>
+            </a:r>
+            <a:r>
+              <a:rPr lang="en-US" altLang="ko-KR" dirty="0"/>
+              <a:t>.</a:t>
+            </a:r>
+          </a:p>
+        </p:txBody>
+      </p:sp>
+      <p:sp>
+        <p:nvSpPr>
+          <p:cNvPr id="4" name="슬라이드 번호 개체 틀 3">
+            <a:extLst>
+              <a:ext uri="{FF2B5EF4-FFF2-40B4-BE49-F238E27FC236}">
+                <a16:creationId xmlns:a16="http://schemas.microsoft.com/office/drawing/2014/main" id="{F2967140-1563-E5EF-78D3-13FB89C7DE0A}"/>
+              </a:ext>
+            </a:extLst>
+          </p:cNvPr>
+          <p:cNvSpPr>
+            <a:spLocks noGrp="1"/>
+          </p:cNvSpPr>
+          <p:nvPr>
+            <p:ph type="sldNum" sz="quarter" idx="5"/>
+          </p:nvPr>
+        </p:nvSpPr>
+        <p:spPr/>
+        <p:txBody>
+          <a:bodyPr/>
+          <a:lstStyle/>
+          <a:p>
+            <a:pPr lvl="0"/>
+            <a:fld id="{16A3BD86-B9C4-48BB-B1BA-5BDB10AF1901}" type="slidenum">
+              <a:rPr lang="ko-KR" altLang="en-US" smtClean="0"/>
+              <a:t>10</a:t>
+            </a:fld>
+            <a:endParaRPr lang="ko-KR" altLang="en-US"/>
+          </a:p>
+        </p:txBody>
+      </p:sp>
+    </p:spTree>
+    <p:extLst>
+      <p:ext uri="{BB962C8B-B14F-4D97-AF65-F5344CB8AC3E}">
+        <p14:creationId xmlns:p14="http://schemas.microsoft.com/office/powerpoint/2010/main" val="4117887622"/>
+      </p:ext>
+    </p:extLst>
+  </p:cSld>
+  <p:clrMapOvr>
+    <a:masterClrMapping/>
+  </p:clrMapOvr>
+</p:notes>
+</file>
+
+<file path=ppt/notesSlides/notesSlide11.xml><?xml version="1.0" encoding="utf-8"?>
+<p:notes xmlns:a="http://schemas.openxmlformats.org/drawingml/2006/main" xmlns:r="http://schemas.openxmlformats.org/officeDocument/2006/relationships" xmlns:p="http://schemas.openxmlformats.org/presentationml/2006/main">
+  <p:cSld>
+    <p:spTree>
+      <p:nvGrpSpPr>
+        <p:cNvPr id="1" name="">
+          <a:extLst>
+            <a:ext uri="{FF2B5EF4-FFF2-40B4-BE49-F238E27FC236}">
               <a16:creationId xmlns:a16="http://schemas.microsoft.com/office/drawing/2014/main" id="{B0EE49DF-01A2-3A8D-39E5-07ED7E651F74}"/>
             </a:ext>
           </a:extLst>
@@ -998,7 +1276,7 @@
             <a:pPr lvl="0"/>
             <a:fld id="{16A3BD86-B9C4-48BB-B1BA-5BDB10AF1901}" type="slidenum">
               <a:rPr lang="ko-KR" altLang="en-US" smtClean="0"/>
-              <a:t>10</a:t>
+              <a:t>11</a:t>
             </a:fld>
             <a:endParaRPr lang="ko-KR" altLang="en-US"/>
           </a:p>
@@ -1017,7 +1295,7 @@
 </p:notes>
 </file>
 
-<file path=ppt/notesSlides/notesSlide11.xml><?xml version="1.0" encoding="utf-8"?>
+<file path=ppt/notesSlides/notesSlide12.xml><?xml version="1.0" encoding="utf-8"?>
 <p:notes xmlns:a="http://schemas.openxmlformats.org/drawingml/2006/main" xmlns:r="http://schemas.openxmlformats.org/officeDocument/2006/relationships" xmlns:p="http://schemas.openxmlformats.org/presentationml/2006/main">
   <p:cSld>
     <p:spTree>
@@ -1117,7 +1395,7 @@
             <a:pPr lvl="0"/>
             <a:fld id="{16A3BD86-B9C4-48BB-B1BA-5BDB10AF1901}" type="slidenum">
               <a:rPr lang="ko-KR" altLang="en-US" smtClean="0"/>
-              <a:t>11</a:t>
+              <a:t>12</a:t>
             </a:fld>
             <a:endParaRPr lang="ko-KR" altLang="en-US"/>
           </a:p>
@@ -1136,7 +1414,7 @@
 </p:notes>
 </file>
 
-<file path=ppt/notesSlides/notesSlide12.xml><?xml version="1.0" encoding="utf-8"?>
+<file path=ppt/notesSlides/notesSlide13.xml><?xml version="1.0" encoding="utf-8"?>
 <p:notes xmlns:a="http://schemas.openxmlformats.org/drawingml/2006/main" xmlns:r="http://schemas.openxmlformats.org/officeDocument/2006/relationships" xmlns:p="http://schemas.openxmlformats.org/presentationml/2006/main">
   <p:cSld>
     <p:spTree>
@@ -1232,7 +1510,7 @@
           <a:p>
             <a:fld id="{16A3BD86-B9C4-48BB-B1BA-5BDB10AF1901}" type="slidenum">
               <a:rPr lang="ko-KR" altLang="en-US" smtClean="0"/>
-              <a:t>12</a:t>
+              <a:t>13</a:t>
             </a:fld>
             <a:endParaRPr lang="ko-KR" altLang="en-US"/>
           </a:p>
@@ -2776,7 +3054,7 @@
         <p:cNvPr id="1" name="">
           <a:extLst>
             <a:ext uri="{FF2B5EF4-FFF2-40B4-BE49-F238E27FC236}">
-              <a16:creationId xmlns:a16="http://schemas.microsoft.com/office/drawing/2014/main" id="{5853F38A-D6A8-AB8C-619F-F7CAFAE0189C}"/>
+              <a16:creationId xmlns:a16="http://schemas.microsoft.com/office/drawing/2014/main" id="{DFE635E4-AB31-296E-1ED9-FC30FCBAF46D}"/>
             </a:ext>
           </a:extLst>
         </p:cNvPr>
@@ -2796,12 +3074,12 @@
           <p:cNvPr id="2" name="슬라이드 이미지 개체 틀 1">
             <a:extLst>
               <a:ext uri="{FF2B5EF4-FFF2-40B4-BE49-F238E27FC236}">
-                <a16:creationId xmlns:a16="http://schemas.microsoft.com/office/drawing/2014/main" id="{A1ADCCB8-0F65-304F-3DF1-8BECCA8C1EB9}"/>
+                <a16:creationId xmlns:a16="http://schemas.microsoft.com/office/drawing/2014/main" id="{95765ACE-303F-29D4-A7F0-97DEA5A80E64}"/>
               </a:ext>
             </a:extLst>
           </p:cNvPr>
           <p:cNvSpPr>
-            <a:spLocks noGrp="1" noRot="1" noChangeAspect="1" noTextEdit="1"/>
+            <a:spLocks noGrp="1" noRot="1" noChangeAspect="1"/>
           </p:cNvSpPr>
           <p:nvPr>
             <p:ph type="sldImg"/>
@@ -2814,7 +3092,7 @@
           <p:cNvPr id="3" name="슬라이드 노트 개체 틀 2">
             <a:extLst>
               <a:ext uri="{FF2B5EF4-FFF2-40B4-BE49-F238E27FC236}">
-                <a16:creationId xmlns:a16="http://schemas.microsoft.com/office/drawing/2014/main" id="{EF53B96C-B14F-7EA6-75AA-2F6BED3B0597}"/>
+                <a16:creationId xmlns:a16="http://schemas.microsoft.com/office/drawing/2014/main" id="{F787314F-9088-CBDA-0B87-D055D6B7B00A}"/>
               </a:ext>
             </a:extLst>
           </p:cNvPr>
@@ -2830,174 +3108,7 @@
           <a:bodyPr/>
           <a:lstStyle/>
           <a:p>
-            <a:pPr lvl="0">
-              <a:defRPr/>
-            </a:pPr>
-            <a:r>
-              <a:rPr lang="ko-KR" altLang="en-US" dirty="0"/>
-              <a:t>성능 평가입니다</a:t>
-            </a:r>
-            <a:r>
-              <a:rPr lang="en-US" altLang="ko-KR" dirty="0"/>
-              <a:t>.</a:t>
-            </a:r>
-          </a:p>
-          <a:p>
-            <a:pPr lvl="0">
-              <a:defRPr/>
-            </a:pPr>
-            <a:r>
-              <a:rPr lang="ko-KR" altLang="en-US" dirty="0"/>
-              <a:t>검증결과 실내 환경에서 </a:t>
-            </a:r>
-            <a:r>
-              <a:rPr lang="en-US" altLang="ko-KR" dirty="0"/>
-              <a:t>4</a:t>
-            </a:r>
-            <a:r>
-              <a:rPr lang="ko-KR" altLang="en-US" dirty="0"/>
-              <a:t>개의 수신부를 </a:t>
-            </a:r>
-            <a:r>
-              <a:rPr lang="en-US" altLang="ko-KR" dirty="0"/>
-              <a:t>5~10m </a:t>
-            </a:r>
-            <a:r>
-              <a:rPr lang="ko-KR" altLang="en-US" dirty="0"/>
-              <a:t>거리에 배치하여 획득한 데이터셋으로 검증을 하였고</a:t>
-            </a:r>
-            <a:r>
-              <a:rPr lang="en-US" altLang="ko-KR" dirty="0"/>
-              <a:t>.</a:t>
-            </a:r>
-          </a:p>
-          <a:p>
-            <a:pPr lvl="0">
-              <a:defRPr/>
-            </a:pPr>
-            <a:r>
-              <a:rPr lang="ko-KR" altLang="en-US" dirty="0"/>
-              <a:t>결과는 표</a:t>
-            </a:r>
-            <a:r>
-              <a:rPr lang="en-US" altLang="ko-KR" dirty="0"/>
-              <a:t>1</a:t>
-            </a:r>
-            <a:r>
-              <a:rPr lang="ko-KR" altLang="en-US" dirty="0"/>
-              <a:t>과 같습니다</a:t>
-            </a:r>
-            <a:r>
-              <a:rPr lang="en-US" altLang="ko-KR" dirty="0"/>
-              <a:t>. </a:t>
-            </a:r>
-          </a:p>
-          <a:p>
-            <a:pPr lvl="0">
-              <a:defRPr/>
-            </a:pPr>
-            <a:r>
-              <a:rPr lang="ko-KR" altLang="en-US" dirty="0"/>
-              <a:t>표</a:t>
-            </a:r>
-            <a:r>
-              <a:rPr lang="en-US" altLang="ko-KR" dirty="0"/>
-              <a:t>2</a:t>
-            </a:r>
-            <a:r>
-              <a:rPr lang="ko-KR" altLang="en-US" dirty="0"/>
-              <a:t>는 타 </a:t>
-            </a:r>
-            <a:r>
-              <a:rPr lang="en-US" altLang="ko-KR" dirty="0"/>
-              <a:t>MOT </a:t>
-            </a:r>
-            <a:r>
-              <a:rPr lang="en-US" altLang="ko-KR" dirty="0" err="1"/>
-              <a:t>Mehod</a:t>
-            </a:r>
-            <a:r>
-              <a:rPr lang="ko-KR" altLang="en-US" dirty="0"/>
-              <a:t>의 </a:t>
-            </a:r>
-            <a:r>
-              <a:rPr lang="en-US" altLang="ko-KR" dirty="0"/>
-              <a:t>MOTA </a:t>
-            </a:r>
-            <a:r>
-              <a:rPr lang="ko-KR" altLang="en-US" dirty="0"/>
-              <a:t>결과인데 </a:t>
-            </a:r>
-            <a:r>
-              <a:rPr lang="en-US" altLang="ko-KR" dirty="0"/>
-              <a:t>KITTI test set </a:t>
-            </a:r>
-            <a:r>
-              <a:rPr lang="ko-KR" altLang="en-US" dirty="0" err="1"/>
-              <a:t>에대한</a:t>
-            </a:r>
-            <a:r>
-              <a:rPr lang="ko-KR" altLang="en-US" dirty="0"/>
-              <a:t> 지표입니다</a:t>
-            </a:r>
-            <a:r>
-              <a:rPr lang="en-US" altLang="ko-KR" dirty="0"/>
-              <a:t>.</a:t>
-            </a:r>
-          </a:p>
-          <a:p>
-            <a:pPr lvl="0">
-              <a:defRPr/>
-            </a:pPr>
-            <a:r>
-              <a:rPr lang="en-US" altLang="ko-KR" dirty="0"/>
-              <a:t>Kitti test set</a:t>
-            </a:r>
-            <a:r>
-              <a:rPr lang="ko-KR" altLang="en-US" dirty="0"/>
-              <a:t>은 자율주행 을 위한 데이터 셋입니다</a:t>
-            </a:r>
-            <a:r>
-              <a:rPr lang="en-US" altLang="ko-KR" dirty="0"/>
-              <a:t>.</a:t>
-            </a:r>
-          </a:p>
-          <a:p>
-            <a:pPr lvl="0">
-              <a:defRPr/>
-            </a:pPr>
-            <a:r>
-              <a:rPr lang="ko-KR" altLang="en-US" dirty="0"/>
-              <a:t>저희가 제안하는 방식은 보다 </a:t>
-            </a:r>
-            <a:r>
-              <a:rPr lang="ko-KR" altLang="en-US" dirty="0" err="1"/>
-              <a:t>쉬운환경임에따라</a:t>
-            </a:r>
-            <a:r>
-              <a:rPr lang="ko-KR" altLang="en-US" dirty="0"/>
-              <a:t> 보다 높은 </a:t>
-            </a:r>
-            <a:r>
-              <a:rPr lang="en-US" altLang="ko-KR" dirty="0"/>
-              <a:t>MOTA </a:t>
-            </a:r>
-            <a:r>
-              <a:rPr lang="ko-KR" altLang="en-US" dirty="0"/>
-              <a:t>결과를 </a:t>
-            </a:r>
-            <a:r>
-              <a:rPr lang="ko-KR" altLang="en-US" dirty="0" err="1"/>
-              <a:t>얻은것을</a:t>
-            </a:r>
-            <a:r>
-              <a:rPr lang="ko-KR" altLang="en-US" dirty="0"/>
-              <a:t> 확인할 수 있습니다</a:t>
-            </a:r>
-            <a:r>
-              <a:rPr lang="en-US" altLang="ko-KR" dirty="0"/>
-              <a:t>.</a:t>
-            </a:r>
+            <a:endParaRPr lang="en-US" altLang="ko-KR" dirty="0"/>
           </a:p>
         </p:txBody>
       </p:sp>
@@ -3006,7 +3117,7 @@
           <p:cNvPr id="4" name="슬라이드 번호 개체 틀 3">
             <a:extLst>
               <a:ext uri="{FF2B5EF4-FFF2-40B4-BE49-F238E27FC236}">
-                <a16:creationId xmlns:a16="http://schemas.microsoft.com/office/drawing/2014/main" id="{F2967140-1563-E5EF-78D3-13FB89C7DE0A}"/>
+                <a16:creationId xmlns:a16="http://schemas.microsoft.com/office/drawing/2014/main" id="{B1251513-EC05-6D68-7441-5632AA17C2A3}"/>
               </a:ext>
             </a:extLst>
           </p:cNvPr>
@@ -3022,7 +3133,6 @@
           <a:bodyPr/>
           <a:lstStyle/>
           <a:p>
-            <a:pPr lvl="0"/>
             <a:fld id="{16A3BD86-B9C4-48BB-B1BA-5BDB10AF1901}" type="slidenum">
               <a:rPr lang="ko-KR" altLang="en-US" smtClean="0"/>
               <a:t>9</a:t>
@@ -3034,7 +3144,7 @@
     </p:spTree>
     <p:extLst>
       <p:ext uri="{BB962C8B-B14F-4D97-AF65-F5344CB8AC3E}">
-        <p14:creationId xmlns:p14="http://schemas.microsoft.com/office/powerpoint/2010/main" val="4117887622"/>
+        <p14:creationId xmlns:p14="http://schemas.microsoft.com/office/powerpoint/2010/main" val="1601387615"/>
       </p:ext>
     </p:extLst>
   </p:cSld>
@@ -3191,7 +3301,7 @@
           <a:p>
             <a:fld id="{24594891-C176-45C6-952F-6646066BB07A}" type="datetime1">
               <a:rPr lang="ko-KR" altLang="en-US" smtClean="0"/>
-              <a:t>2026-01-28</a:t>
+              <a:t>2026-01-29</a:t>
             </a:fld>
             <a:endParaRPr lang="ko-KR" altLang="en-US"/>
           </a:p>
@@ -3385,7 +3495,7 @@
           <a:p>
             <a:fld id="{8E684535-2B26-40AE-98B0-725BE7CC6FA8}" type="datetime1">
               <a:rPr lang="ko-KR" altLang="en-US" smtClean="0"/>
-              <a:t>2026-01-28</a:t>
+              <a:t>2026-01-29</a:t>
             </a:fld>
             <a:endParaRPr lang="ko-KR" altLang="en-US"/>
           </a:p>
@@ -3593,7 +3703,7 @@
           <a:p>
             <a:fld id="{AA481038-2E04-4EFF-AFD3-D1E32DD6BF0A}" type="datetime1">
               <a:rPr lang="ko-KR" altLang="en-US" smtClean="0"/>
-              <a:t>2026-01-28</a:t>
+              <a:t>2026-01-29</a:t>
             </a:fld>
             <a:endParaRPr lang="ko-KR" altLang="en-US"/>
           </a:p>
@@ -3791,7 +3901,7 @@
           <a:p>
             <a:fld id="{8A277154-35AB-4BEF-ABD2-72B454421146}" type="datetime1">
               <a:rPr lang="ko-KR" altLang="en-US" smtClean="0"/>
-              <a:t>2026-01-28</a:t>
+              <a:t>2026-01-29</a:t>
             </a:fld>
             <a:endParaRPr lang="ko-KR" altLang="en-US"/>
           </a:p>
@@ -4066,7 +4176,7 @@
           <a:p>
             <a:fld id="{DB87E407-6B96-4B20-A56B-622FAA2C9F1E}" type="datetime1">
               <a:rPr lang="ko-KR" altLang="en-US" smtClean="0"/>
-              <a:t>2026-01-28</a:t>
+              <a:t>2026-01-29</a:t>
             </a:fld>
             <a:endParaRPr lang="ko-KR" altLang="en-US"/>
           </a:p>
@@ -4331,7 +4441,7 @@
           <a:p>
             <a:fld id="{1543554E-5C37-432E-B5B0-5F06A10FB84D}" type="datetime1">
               <a:rPr lang="ko-KR" altLang="en-US" smtClean="0"/>
-              <a:t>2026-01-28</a:t>
+              <a:t>2026-01-29</a:t>
             </a:fld>
             <a:endParaRPr lang="ko-KR" altLang="en-US"/>
           </a:p>
@@ -4743,7 +4853,7 @@
           <a:p>
             <a:fld id="{FACB1258-8CD3-4C4C-96C6-E0292624AFA2}" type="datetime1">
               <a:rPr lang="ko-KR" altLang="en-US" smtClean="0"/>
-              <a:t>2026-01-28</a:t>
+              <a:t>2026-01-29</a:t>
             </a:fld>
             <a:endParaRPr lang="ko-KR" altLang="en-US"/>
           </a:p>
@@ -4884,7 +4994,7 @@
           <a:p>
             <a:fld id="{64A2ECE2-7E19-4C0D-9ADC-E9A8A6CBE1BB}" type="datetime1">
               <a:rPr lang="ko-KR" altLang="en-US" smtClean="0"/>
-              <a:t>2026-01-28</a:t>
+              <a:t>2026-01-29</a:t>
             </a:fld>
             <a:endParaRPr lang="ko-KR" altLang="en-US"/>
           </a:p>
@@ -4997,7 +5107,7 @@
           <a:p>
             <a:fld id="{FA9215E5-75A1-418B-B4F5-C9812F71A2DB}" type="datetime1">
               <a:rPr lang="ko-KR" altLang="en-US" smtClean="0"/>
-              <a:t>2026-01-28</a:t>
+              <a:t>2026-01-29</a:t>
             </a:fld>
             <a:endParaRPr lang="ko-KR" altLang="en-US"/>
           </a:p>
@@ -5308,7 +5418,7 @@
           <a:p>
             <a:fld id="{CAF24838-9398-4F49-8728-9E6AB80DF08A}" type="datetime1">
               <a:rPr lang="ko-KR" altLang="en-US" smtClean="0"/>
-              <a:t>2026-01-28</a:t>
+              <a:t>2026-01-29</a:t>
             </a:fld>
             <a:endParaRPr lang="ko-KR" altLang="en-US"/>
           </a:p>
@@ -5596,7 +5706,7 @@
           <a:p>
             <a:fld id="{A727F419-0948-4C2B-97E0-7038E3D15E60}" type="datetime1">
               <a:rPr lang="ko-KR" altLang="en-US" smtClean="0"/>
-              <a:t>2026-01-28</a:t>
+              <a:t>2026-01-29</a:t>
             </a:fld>
             <a:endParaRPr lang="ko-KR" altLang="en-US"/>
           </a:p>
@@ -5837,7 +5947,7 @@
           <a:p>
             <a:fld id="{8EBB48B8-B1C4-4561-8293-340E4E89454A}" type="datetime1">
               <a:rPr lang="ko-KR" altLang="en-US" smtClean="0"/>
-              <a:t>2026-01-28</a:t>
+              <a:t>2026-01-29</a:t>
             </a:fld>
             <a:endParaRPr lang="ko-KR" altLang="en-US"/>
           </a:p>
@@ -6689,6 +6799,1175 @@
         <p:cNvPr id="1" name="">
           <a:extLst>
             <a:ext uri="{FF2B5EF4-FFF2-40B4-BE49-F238E27FC236}">
+              <a16:creationId xmlns:a16="http://schemas.microsoft.com/office/drawing/2014/main" id="{F6935EE4-9FA8-A41A-FDE5-23286AA1C52D}"/>
+            </a:ext>
+          </a:extLst>
+        </p:cNvPr>
+        <p:cNvGrpSpPr/>
+        <p:nvPr/>
+      </p:nvGrpSpPr>
+      <p:grpSpPr>
+        <a:xfrm>
+          <a:off x="0" y="0"/>
+          <a:ext cx="0" cy="0"/>
+          <a:chOff x="0" y="0"/>
+          <a:chExt cx="0" cy="0"/>
+        </a:xfrm>
+      </p:grpSpPr>
+      <p:sp>
+        <p:nvSpPr>
+          <p:cNvPr id="11" name="직사각형 10">
+            <a:extLst>
+              <a:ext uri="{FF2B5EF4-FFF2-40B4-BE49-F238E27FC236}">
+                <a16:creationId xmlns:a16="http://schemas.microsoft.com/office/drawing/2014/main" id="{350AC225-BD28-A372-8F78-98DB416A587E}"/>
+              </a:ext>
+            </a:extLst>
+          </p:cNvPr>
+          <p:cNvSpPr/>
+          <p:nvPr/>
+        </p:nvSpPr>
+        <p:spPr>
+          <a:xfrm>
+            <a:off x="0" y="6536360"/>
+            <a:ext cx="12192000" cy="323240"/>
+          </a:xfrm>
+          <a:prstGeom prst="rect">
+            <a:avLst/>
+          </a:prstGeom>
+          <a:solidFill>
+            <a:srgbClr val="5894CF"/>
+          </a:solidFill>
+          <a:ln>
+            <a:noFill/>
+          </a:ln>
+        </p:spPr>
+        <p:style>
+          <a:lnRef idx="2">
+            <a:schemeClr val="accent1">
+              <a:shade val="15000"/>
+            </a:schemeClr>
+          </a:lnRef>
+          <a:fillRef idx="1">
+            <a:schemeClr val="accent1"/>
+          </a:fillRef>
+          <a:effectRef idx="0">
+            <a:schemeClr val="accent1"/>
+          </a:effectRef>
+          <a:fontRef idx="minor">
+            <a:schemeClr val="lt1"/>
+          </a:fontRef>
+        </p:style>
+        <p:txBody>
+          <a:bodyPr anchor="ctr"/>
+          <a:lstStyle/>
+          <a:p>
+            <a:pPr lvl="0">
+              <a:defRPr/>
+            </a:pPr>
+            <a:r>
+              <a:rPr lang="en-US" altLang="ko-KR" sz="800" dirty="0"/>
+              <a:t>[5] X. Wang </a:t>
+            </a:r>
+            <a:r>
+              <a:rPr lang="en-US" altLang="ko-KR" sz="800" i="1" dirty="0"/>
+              <a:t>et al</a:t>
+            </a:r>
+            <a:r>
+              <a:rPr lang="en-US" altLang="ko-KR" sz="800" dirty="0"/>
+              <a:t>., "</a:t>
+            </a:r>
+            <a:r>
+              <a:rPr lang="en-US" altLang="ko-KR" sz="800" dirty="0" err="1"/>
+              <a:t>MCTrack</a:t>
+            </a:r>
+            <a:r>
+              <a:rPr lang="en-US" altLang="ko-KR" sz="800" dirty="0"/>
+              <a:t>: A Unified 3D Multi-Object Tracking Framework for Autonomous Driving," </a:t>
+            </a:r>
+            <a:r>
+              <a:rPr lang="en-US" altLang="ko-KR" sz="800" i="1" dirty="0"/>
+              <a:t>2025 IEEE/RSJ International Conference on Intelligent Robots and Systems (IROS)</a:t>
+            </a:r>
+            <a:r>
+              <a:rPr lang="en-US" altLang="ko-KR" sz="800" dirty="0"/>
+              <a:t>, Hangzhou, China, 2025                                                           </a:t>
+            </a:r>
+            <a:r>
+              <a:rPr lang="en-US" altLang="ko-KR" dirty="0"/>
+              <a:t>8</a:t>
+            </a:r>
+          </a:p>
+        </p:txBody>
+      </p:sp>
+      <p:sp>
+        <p:nvSpPr>
+          <p:cNvPr id="12" name="직사각형 11">
+            <a:extLst>
+              <a:ext uri="{FF2B5EF4-FFF2-40B4-BE49-F238E27FC236}">
+                <a16:creationId xmlns:a16="http://schemas.microsoft.com/office/drawing/2014/main" id="{9FC5284B-96D8-ED3C-F1C5-146E487D93FB}"/>
+              </a:ext>
+            </a:extLst>
+          </p:cNvPr>
+          <p:cNvSpPr/>
+          <p:nvPr/>
+        </p:nvSpPr>
+        <p:spPr>
+          <a:xfrm>
+            <a:off x="-7882" y="0"/>
+            <a:ext cx="12230704" cy="6537960"/>
+          </a:xfrm>
+          <a:prstGeom prst="rect">
+            <a:avLst/>
+          </a:prstGeom>
+          <a:solidFill>
+            <a:srgbClr val="EFF3F8"/>
+          </a:solidFill>
+        </p:spPr>
+        <p:style>
+          <a:lnRef idx="2">
+            <a:schemeClr val="accent1">
+              <a:shade val="15000"/>
+            </a:schemeClr>
+          </a:lnRef>
+          <a:fillRef idx="1">
+            <a:schemeClr val="accent1"/>
+          </a:fillRef>
+          <a:effectRef idx="0">
+            <a:schemeClr val="accent1"/>
+          </a:effectRef>
+          <a:fontRef idx="minor">
+            <a:schemeClr val="lt1"/>
+          </a:fontRef>
+        </p:style>
+        <p:txBody>
+          <a:bodyPr anchor="ctr"/>
+          <a:lstStyle/>
+          <a:p>
+            <a:pPr lvl="0" algn="ctr">
+              <a:defRPr/>
+            </a:pPr>
+            <a:endParaRPr lang="en-US" altLang="ko-KR" dirty="0">
+              <a:solidFill>
+                <a:schemeClr val="tx1"/>
+              </a:solidFill>
+              <a:latin typeface="HY헤드라인M"/>
+              <a:ea typeface="HY헤드라인M"/>
+            </a:endParaRPr>
+          </a:p>
+        </p:txBody>
+      </p:sp>
+      <p:sp>
+        <p:nvSpPr>
+          <p:cNvPr id="16" name="직사각형 15">
+            <a:extLst>
+              <a:ext uri="{FF2B5EF4-FFF2-40B4-BE49-F238E27FC236}">
+                <a16:creationId xmlns:a16="http://schemas.microsoft.com/office/drawing/2014/main" id="{23117118-068C-1061-FEB3-0573061E3184}"/>
+              </a:ext>
+            </a:extLst>
+          </p:cNvPr>
+          <p:cNvSpPr/>
+          <p:nvPr/>
+        </p:nvSpPr>
+        <p:spPr>
+          <a:xfrm>
+            <a:off x="210786" y="149472"/>
+            <a:ext cx="277368" cy="539496"/>
+          </a:xfrm>
+          <a:prstGeom prst="rect">
+            <a:avLst/>
+          </a:prstGeom>
+          <a:solidFill>
+            <a:srgbClr val="89C1EA"/>
+          </a:solidFill>
+          <a:ln>
+            <a:noFill/>
+          </a:ln>
+        </p:spPr>
+        <p:style>
+          <a:lnRef idx="2">
+            <a:schemeClr val="accent1">
+              <a:shade val="15000"/>
+            </a:schemeClr>
+          </a:lnRef>
+          <a:fillRef idx="1">
+            <a:schemeClr val="accent1"/>
+          </a:fillRef>
+          <a:effectRef idx="0">
+            <a:schemeClr val="accent1"/>
+          </a:effectRef>
+          <a:fontRef idx="minor">
+            <a:schemeClr val="lt1"/>
+          </a:fontRef>
+        </p:style>
+        <p:txBody>
+          <a:bodyPr anchor="ctr"/>
+          <a:lstStyle/>
+          <a:p>
+            <a:pPr lvl="0" algn="ctr">
+              <a:defRPr/>
+            </a:pPr>
+            <a:endParaRPr lang="ko-KR" altLang="en-US"/>
+          </a:p>
+        </p:txBody>
+      </p:sp>
+      <p:sp>
+        <p:nvSpPr>
+          <p:cNvPr id="15" name="직사각형 14">
+            <a:extLst>
+              <a:ext uri="{FF2B5EF4-FFF2-40B4-BE49-F238E27FC236}">
+                <a16:creationId xmlns:a16="http://schemas.microsoft.com/office/drawing/2014/main" id="{40D5AABD-7ED9-FCA1-3D7E-A80F1136E2EC}"/>
+              </a:ext>
+            </a:extLst>
+          </p:cNvPr>
+          <p:cNvSpPr/>
+          <p:nvPr/>
+        </p:nvSpPr>
+        <p:spPr>
+          <a:xfrm>
+            <a:off x="305274" y="79368"/>
+            <a:ext cx="5540634" cy="539496"/>
+          </a:xfrm>
+          <a:prstGeom prst="rect">
+            <a:avLst/>
+          </a:prstGeom>
+          <a:solidFill>
+            <a:srgbClr val="5894CF"/>
+          </a:solidFill>
+          <a:ln>
+            <a:noFill/>
+          </a:ln>
+        </p:spPr>
+        <p:style>
+          <a:lnRef idx="2">
+            <a:schemeClr val="accent1">
+              <a:shade val="15000"/>
+            </a:schemeClr>
+          </a:lnRef>
+          <a:fillRef idx="1">
+            <a:schemeClr val="accent1"/>
+          </a:fillRef>
+          <a:effectRef idx="0">
+            <a:schemeClr val="accent1"/>
+          </a:effectRef>
+          <a:fontRef idx="minor">
+            <a:schemeClr val="lt1"/>
+          </a:fontRef>
+        </p:style>
+        <p:txBody>
+          <a:bodyPr anchor="ctr"/>
+          <a:lstStyle/>
+          <a:p>
+            <a:pPr lvl="0" algn="ctr">
+              <a:defRPr/>
+            </a:pPr>
+            <a:r>
+              <a:rPr lang="ko-KR" altLang="en-US" dirty="0">
+                <a:solidFill>
+                  <a:schemeClr val="tx1"/>
+                </a:solidFill>
+                <a:latin typeface="HY헤드라인M"/>
+                <a:ea typeface="HY헤드라인M"/>
+              </a:rPr>
+              <a:t>성능 평가</a:t>
+            </a:r>
+            <a:endParaRPr lang="en-US" altLang="ko-KR" dirty="0">
+              <a:solidFill>
+                <a:schemeClr val="tx1"/>
+              </a:solidFill>
+              <a:latin typeface="HY헤드라인M"/>
+              <a:ea typeface="HY헤드라인M"/>
+            </a:endParaRPr>
+          </a:p>
+        </p:txBody>
+      </p:sp>
+      <p:graphicFrame>
+        <p:nvGraphicFramePr>
+          <p:cNvPr id="2" name="표 1">
+            <a:extLst>
+              <a:ext uri="{FF2B5EF4-FFF2-40B4-BE49-F238E27FC236}">
+                <a16:creationId xmlns:a16="http://schemas.microsoft.com/office/drawing/2014/main" id="{C071F9A1-9B27-6ADE-31A5-C8FF5C811BDE}"/>
+              </a:ext>
+            </a:extLst>
+          </p:cNvPr>
+          <p:cNvGraphicFramePr>
+            <a:graphicFrameLocks noGrp="1"/>
+          </p:cNvGraphicFramePr>
+          <p:nvPr>
+            <p:extLst>
+              <p:ext uri="{D42A27DB-BD31-4B8C-83A1-F6EECF244321}">
+                <p14:modId xmlns:p14="http://schemas.microsoft.com/office/powerpoint/2010/main" val="1959343741"/>
+              </p:ext>
+            </p:extLst>
+          </p:nvPr>
+        </p:nvGraphicFramePr>
+        <p:xfrm>
+          <a:off x="368555" y="1658833"/>
+          <a:ext cx="5739890" cy="1837374"/>
+        </p:xfrm>
+        <a:graphic>
+          <a:graphicData uri="http://schemas.openxmlformats.org/drawingml/2006/table">
+            <a:tbl>
+              <a:tblPr firstRow="1" bandRow="1">
+                <a:tableStyleId>{5C22544A-7EE6-4342-B048-85BDC9FD1C3A}</a:tableStyleId>
+              </a:tblPr>
+              <a:tblGrid>
+                <a:gridCol w="4226135">
+                  <a:extLst>
+                    <a:ext uri="{9D8B030D-6E8A-4147-A177-3AD203B41FA5}">
+                      <a16:colId xmlns:a16="http://schemas.microsoft.com/office/drawing/2014/main" val="1248245821"/>
+                    </a:ext>
+                  </a:extLst>
+                </a:gridCol>
+                <a:gridCol w="1513755">
+                  <a:extLst>
+                    <a:ext uri="{9D8B030D-6E8A-4147-A177-3AD203B41FA5}">
+                      <a16:colId xmlns:a16="http://schemas.microsoft.com/office/drawing/2014/main" val="1363305588"/>
+                    </a:ext>
+                  </a:extLst>
+                </a:gridCol>
+              </a:tblGrid>
+              <a:tr h="306229">
+                <a:tc>
+                  <a:txBody>
+                    <a:bodyPr/>
+                    <a:lstStyle/>
+                    <a:p>
+                      <a:pPr algn="ctr" latinLnBrk="1"/>
+                      <a:r>
+                        <a:rPr lang="ko-KR" altLang="en-US" sz="1300" dirty="0"/>
+                        <a:t>파라미터</a:t>
+                      </a:r>
+                    </a:p>
+                  </a:txBody>
+                  <a:tcPr/>
+                </a:tc>
+                <a:tc>
+                  <a:txBody>
+                    <a:bodyPr/>
+                    <a:lstStyle/>
+                    <a:p>
+                      <a:pPr algn="ctr" latinLnBrk="1"/>
+                      <a:r>
+                        <a:rPr lang="ko-KR" altLang="en-US" sz="1300"/>
+                        <a:t>값</a:t>
+                      </a:r>
+                      <a:endParaRPr lang="ko-KR" altLang="en-US" sz="1300" dirty="0"/>
+                    </a:p>
+                  </a:txBody>
+                  <a:tcPr/>
+                </a:tc>
+                <a:extLst>
+                  <a:ext uri="{0D108BD9-81ED-4DB2-BD59-A6C34878D82A}">
+                    <a16:rowId xmlns:a16="http://schemas.microsoft.com/office/drawing/2014/main" val="1437392871"/>
+                  </a:ext>
+                </a:extLst>
+              </a:tr>
+              <a:tr h="306229">
+                <a:tc>
+                  <a:txBody>
+                    <a:bodyPr/>
+                    <a:lstStyle/>
+                    <a:p>
+                      <a:pPr algn="ctr" latinLnBrk="1"/>
+                      <a:r>
+                        <a:rPr lang="ko-KR" altLang="en-US" sz="1300" b="0" dirty="0"/>
+                        <a:t>실제 타겟 수</a:t>
+                      </a:r>
+                    </a:p>
+                  </a:txBody>
+                  <a:tcPr/>
+                </a:tc>
+                <a:tc>
+                  <a:txBody>
+                    <a:bodyPr/>
+                    <a:lstStyle/>
+                    <a:p>
+                      <a:pPr algn="ctr" latinLnBrk="1"/>
+                      <a:r>
+                        <a:rPr lang="en-US" altLang="ko-KR" sz="1300" b="0" dirty="0"/>
+                        <a:t>4 </a:t>
+                      </a:r>
+                      <a:r>
+                        <a:rPr lang="ko-KR" altLang="en-US" sz="1300" b="0" dirty="0"/>
+                        <a:t>개</a:t>
+                      </a:r>
+                    </a:p>
+                  </a:txBody>
+                  <a:tcPr/>
+                </a:tc>
+                <a:extLst>
+                  <a:ext uri="{0D108BD9-81ED-4DB2-BD59-A6C34878D82A}">
+                    <a16:rowId xmlns:a16="http://schemas.microsoft.com/office/drawing/2014/main" val="3017696609"/>
+                  </a:ext>
+                </a:extLst>
+              </a:tr>
+              <a:tr h="306229">
+                <a:tc>
+                  <a:txBody>
+                    <a:bodyPr/>
+                    <a:lstStyle/>
+                    <a:p>
+                      <a:pPr algn="ctr" latinLnBrk="1"/>
+                      <a:r>
+                        <a:rPr lang="ko-KR" altLang="en-US" sz="1300" b="0" dirty="0"/>
+                        <a:t>식별 타겟 수</a:t>
+                      </a:r>
+                    </a:p>
+                  </a:txBody>
+                  <a:tcPr/>
+                </a:tc>
+                <a:tc>
+                  <a:txBody>
+                    <a:bodyPr/>
+                    <a:lstStyle/>
+                    <a:p>
+                      <a:pPr algn="ctr" latinLnBrk="1"/>
+                      <a:r>
+                        <a:rPr lang="en-US" altLang="ko-KR" sz="1300" b="0" dirty="0"/>
+                        <a:t>10 </a:t>
+                      </a:r>
+                      <a:r>
+                        <a:rPr lang="ko-KR" altLang="en-US" sz="1300" b="0" dirty="0"/>
+                        <a:t>개</a:t>
+                      </a:r>
+                    </a:p>
+                  </a:txBody>
+                  <a:tcPr/>
+                </a:tc>
+                <a:extLst>
+                  <a:ext uri="{0D108BD9-81ED-4DB2-BD59-A6C34878D82A}">
+                    <a16:rowId xmlns:a16="http://schemas.microsoft.com/office/drawing/2014/main" val="1383321197"/>
+                  </a:ext>
+                </a:extLst>
+              </a:tr>
+              <a:tr h="306229">
+                <a:tc>
+                  <a:txBody>
+                    <a:bodyPr/>
+                    <a:lstStyle/>
+                    <a:p>
+                      <a:pPr algn="ctr" latinLnBrk="1"/>
+                      <a:r>
+                        <a:rPr lang="en-US" altLang="ko-KR" sz="1300" b="0" dirty="0"/>
+                        <a:t>MOTA(</a:t>
+                      </a:r>
+                      <a:r>
+                        <a:rPr lang="ko-KR" altLang="en-US" sz="1300" b="0" dirty="0"/>
+                        <a:t>↑</a:t>
+                      </a:r>
+                      <a:r>
+                        <a:rPr lang="en-US" altLang="ko-KR" sz="1300" b="0" dirty="0"/>
+                        <a:t>)</a:t>
+                      </a:r>
+                      <a:endParaRPr lang="ko-KR" altLang="en-US" sz="1300" b="0" dirty="0"/>
+                    </a:p>
+                  </a:txBody>
+                  <a:tcPr/>
+                </a:tc>
+                <a:tc>
+                  <a:txBody>
+                    <a:bodyPr/>
+                    <a:lstStyle/>
+                    <a:p>
+                      <a:pPr algn="ctr" latinLnBrk="1"/>
+                      <a:r>
+                        <a:rPr lang="en-US" altLang="ko-KR" sz="1300" b="0" dirty="0"/>
+                        <a:t>94.5%</a:t>
+                      </a:r>
+                      <a:endParaRPr lang="ko-KR" altLang="en-US" sz="1300" b="0" dirty="0"/>
+                    </a:p>
+                  </a:txBody>
+                  <a:tcPr/>
+                </a:tc>
+                <a:extLst>
+                  <a:ext uri="{0D108BD9-81ED-4DB2-BD59-A6C34878D82A}">
+                    <a16:rowId xmlns:a16="http://schemas.microsoft.com/office/drawing/2014/main" val="1045870170"/>
+                  </a:ext>
+                </a:extLst>
+              </a:tr>
+              <a:tr h="306229">
+                <a:tc>
+                  <a:txBody>
+                    <a:bodyPr/>
+                    <a:lstStyle/>
+                    <a:p>
+                      <a:pPr algn="ctr" latinLnBrk="1"/>
+                      <a:r>
+                        <a:rPr lang="en-US" altLang="ko-KR" sz="1300" b="0" dirty="0"/>
+                        <a:t>IDSW(</a:t>
+                      </a:r>
+                      <a:r>
+                        <a:rPr lang="ko-KR" altLang="en-US" sz="1300" b="0" dirty="0"/>
+                        <a:t>↓</a:t>
+                      </a:r>
+                      <a:r>
+                        <a:rPr lang="en-US" altLang="ko-KR" sz="1300" b="0" dirty="0"/>
+                        <a:t>)</a:t>
+                      </a:r>
+                      <a:endParaRPr lang="ko-KR" altLang="en-US" sz="1300" b="0" dirty="0"/>
+                    </a:p>
+                  </a:txBody>
+                  <a:tcPr/>
+                </a:tc>
+                <a:tc>
+                  <a:txBody>
+                    <a:bodyPr/>
+                    <a:lstStyle/>
+                    <a:p>
+                      <a:pPr algn="ctr" latinLnBrk="1"/>
+                      <a:r>
+                        <a:rPr lang="en-US" altLang="ko-KR" sz="1300" b="0" dirty="0"/>
+                        <a:t>6</a:t>
+                      </a:r>
+                      <a:r>
+                        <a:rPr lang="ko-KR" altLang="en-US" sz="1300" b="0" dirty="0"/>
+                        <a:t>회</a:t>
+                      </a:r>
+                    </a:p>
+                  </a:txBody>
+                  <a:tcPr/>
+                </a:tc>
+                <a:extLst>
+                  <a:ext uri="{0D108BD9-81ED-4DB2-BD59-A6C34878D82A}">
+                    <a16:rowId xmlns:a16="http://schemas.microsoft.com/office/drawing/2014/main" val="133207077"/>
+                  </a:ext>
+                </a:extLst>
+              </a:tr>
+              <a:tr h="306229">
+                <a:tc>
+                  <a:txBody>
+                    <a:bodyPr/>
+                    <a:lstStyle/>
+                    <a:p>
+                      <a:pPr algn="ctr" latinLnBrk="1"/>
+                      <a:r>
+                        <a:rPr lang="en-US" altLang="ko-KR" sz="1300" b="0" dirty="0"/>
+                        <a:t>ID</a:t>
+                      </a:r>
+                      <a:r>
+                        <a:rPr lang="ko-KR" altLang="en-US" sz="1300" b="0" dirty="0"/>
+                        <a:t> </a:t>
+                      </a:r>
+                      <a:r>
+                        <a:rPr lang="en-US" altLang="ko-KR" sz="1300" b="0" dirty="0"/>
+                        <a:t>Purity(</a:t>
+                      </a:r>
+                      <a:r>
+                        <a:rPr lang="ko-KR" altLang="en-US" sz="1300" b="0" dirty="0"/>
+                        <a:t>↑</a:t>
+                      </a:r>
+                      <a:r>
+                        <a:rPr lang="en-US" altLang="ko-KR" sz="1300" b="0" dirty="0"/>
+                        <a:t>)</a:t>
+                      </a:r>
+                      <a:endParaRPr lang="ko-KR" altLang="en-US" sz="1300" b="0" dirty="0"/>
+                    </a:p>
+                  </a:txBody>
+                  <a:tcPr/>
+                </a:tc>
+                <a:tc>
+                  <a:txBody>
+                    <a:bodyPr/>
+                    <a:lstStyle/>
+                    <a:p>
+                      <a:pPr algn="ctr" latinLnBrk="1"/>
+                      <a:r>
+                        <a:rPr lang="en-US" altLang="ko-KR" sz="1300" b="0" dirty="0"/>
+                        <a:t>100%</a:t>
+                      </a:r>
+                      <a:endParaRPr lang="ko-KR" altLang="en-US" sz="1300" b="0" dirty="0"/>
+                    </a:p>
+                  </a:txBody>
+                  <a:tcPr/>
+                </a:tc>
+                <a:extLst>
+                  <a:ext uri="{0D108BD9-81ED-4DB2-BD59-A6C34878D82A}">
+                    <a16:rowId xmlns:a16="http://schemas.microsoft.com/office/drawing/2014/main" val="1531617306"/>
+                  </a:ext>
+                </a:extLst>
+              </a:tr>
+            </a:tbl>
+          </a:graphicData>
+        </a:graphic>
+      </p:graphicFrame>
+      <p:sp>
+        <p:nvSpPr>
+          <p:cNvPr id="3" name="TextBox 2">
+            <a:extLst>
+              <a:ext uri="{FF2B5EF4-FFF2-40B4-BE49-F238E27FC236}">
+                <a16:creationId xmlns:a16="http://schemas.microsoft.com/office/drawing/2014/main" id="{1823AAD7-B6FC-EB0A-B77C-6BA4E6C84CCE}"/>
+              </a:ext>
+            </a:extLst>
+          </p:cNvPr>
+          <p:cNvSpPr txBox="1"/>
+          <p:nvPr/>
+        </p:nvSpPr>
+        <p:spPr>
+          <a:xfrm>
+            <a:off x="1" y="881815"/>
+            <a:ext cx="12191999" cy="461665"/>
+          </a:xfrm>
+          <a:prstGeom prst="rect">
+            <a:avLst/>
+          </a:prstGeom>
+          <a:noFill/>
+        </p:spPr>
+        <p:txBody>
+          <a:bodyPr wrap="square" rtlCol="0">
+            <a:spAutoFit/>
+          </a:bodyPr>
+          <a:lstStyle/>
+          <a:p>
+            <a:r>
+              <a:rPr lang="ko-KR" altLang="en-US" sz="2400" b="1" dirty="0"/>
+              <a:t>  ■ 검증 결과</a:t>
+            </a:r>
+          </a:p>
+        </p:txBody>
+      </p:sp>
+      <p:sp>
+        <p:nvSpPr>
+          <p:cNvPr id="4" name="TextBox 3">
+            <a:extLst>
+              <a:ext uri="{FF2B5EF4-FFF2-40B4-BE49-F238E27FC236}">
+                <a16:creationId xmlns:a16="http://schemas.microsoft.com/office/drawing/2014/main" id="{4131AD9A-0C01-EF4A-EC54-56F0CDCAB555}"/>
+              </a:ext>
+            </a:extLst>
+          </p:cNvPr>
+          <p:cNvSpPr txBox="1"/>
+          <p:nvPr/>
+        </p:nvSpPr>
+        <p:spPr>
+          <a:xfrm>
+            <a:off x="305274" y="4061895"/>
+            <a:ext cx="8019576" cy="1477328"/>
+          </a:xfrm>
+          <a:prstGeom prst="rect">
+            <a:avLst/>
+          </a:prstGeom>
+          <a:noFill/>
+        </p:spPr>
+        <p:txBody>
+          <a:bodyPr wrap="square" rtlCol="0">
+            <a:spAutoFit/>
+          </a:bodyPr>
+          <a:lstStyle/>
+          <a:p>
+            <a:pPr marL="285750" indent="-285750">
+              <a:buFont typeface="Arial" panose="020B0604020202020204" pitchFamily="34" charset="0"/>
+              <a:buChar char="•"/>
+            </a:pPr>
+            <a:r>
+              <a:rPr lang="ko-KR" altLang="en-US" b="0" i="0" dirty="0">
+                <a:latin typeface="Cambria Math" panose="02040503050406030204" pitchFamily="18" charset="0"/>
+              </a:rPr>
+              <a:t>실내 환경에서 </a:t>
+            </a:r>
+            <a:r>
+              <a:rPr lang="en-US" altLang="ko-KR" b="0" i="0" dirty="0">
+                <a:latin typeface="Cambria Math" panose="02040503050406030204" pitchFamily="18" charset="0"/>
+              </a:rPr>
+              <a:t>5-10m </a:t>
+            </a:r>
+            <a:r>
+              <a:rPr lang="ko-KR" altLang="en-US" b="0" i="0" dirty="0">
+                <a:latin typeface="Cambria Math" panose="02040503050406030204" pitchFamily="18" charset="0"/>
+              </a:rPr>
+              <a:t>거리에 수신부를 배치하여 획득한 데이터 셋 활용</a:t>
+            </a:r>
+            <a:r>
+              <a:rPr lang="en-US" altLang="ko-KR" b="0" i="0" dirty="0">
+                <a:latin typeface="Cambria Math" panose="02040503050406030204" pitchFamily="18" charset="0"/>
+              </a:rPr>
+              <a:t>.</a:t>
+            </a:r>
+          </a:p>
+          <a:p>
+            <a:pPr marL="285750" indent="-285750">
+              <a:buFont typeface="Arial" panose="020B0604020202020204" pitchFamily="34" charset="0"/>
+              <a:buChar char="•"/>
+            </a:pPr>
+            <a:endParaRPr lang="en-US" altLang="ko-KR" dirty="0"/>
+          </a:p>
+          <a:p>
+            <a:pPr marL="285750" indent="-285750">
+              <a:buFont typeface="Arial" panose="020B0604020202020204" pitchFamily="34" charset="0"/>
+              <a:buChar char="•"/>
+            </a:pPr>
+            <a:r>
+              <a:rPr lang="ko-KR" altLang="en-US" dirty="0"/>
+              <a:t>표</a:t>
+            </a:r>
+            <a:r>
+              <a:rPr lang="en-US" altLang="ko-KR" dirty="0"/>
+              <a:t>2</a:t>
+            </a:r>
+            <a:r>
+              <a:rPr lang="ko-KR" altLang="en-US" dirty="0"/>
+              <a:t>는 </a:t>
+            </a:r>
+            <a:r>
+              <a:rPr lang="en-US" altLang="ko-KR" dirty="0"/>
+              <a:t>KITTI test set </a:t>
+            </a:r>
+            <a:r>
+              <a:rPr lang="ko-KR" altLang="en-US" dirty="0" err="1"/>
+              <a:t>에대한</a:t>
+            </a:r>
+            <a:r>
+              <a:rPr lang="ko-KR" altLang="en-US" dirty="0"/>
+              <a:t> </a:t>
+            </a:r>
+            <a:r>
+              <a:rPr lang="en-US" altLang="ko-KR" dirty="0"/>
+              <a:t>MOTA </a:t>
+            </a:r>
+            <a:r>
+              <a:rPr lang="ko-KR" altLang="en-US" dirty="0"/>
+              <a:t>결과표로 </a:t>
+            </a:r>
+            <a:r>
+              <a:rPr lang="en-US" altLang="ko-KR" dirty="0"/>
+              <a:t>90%</a:t>
+            </a:r>
+            <a:r>
+              <a:rPr lang="ko-KR" altLang="en-US" dirty="0"/>
+              <a:t>대의 결과를 보여줌</a:t>
+            </a:r>
+            <a:r>
+              <a:rPr lang="en-US" altLang="ko-KR" dirty="0"/>
+              <a:t>[5].</a:t>
+            </a:r>
+          </a:p>
+          <a:p>
+            <a:pPr marL="285750" indent="-285750">
+              <a:buFont typeface="Arial" panose="020B0604020202020204" pitchFamily="34" charset="0"/>
+              <a:buChar char="•"/>
+            </a:pPr>
+            <a:endParaRPr lang="en-US" altLang="ko-KR" dirty="0"/>
+          </a:p>
+          <a:p>
+            <a:pPr marL="285750" indent="-285750">
+              <a:buFont typeface="Arial" panose="020B0604020202020204" pitchFamily="34" charset="0"/>
+              <a:buChar char="•"/>
+            </a:pPr>
+            <a:r>
+              <a:rPr lang="ko-KR" altLang="en-US" dirty="0"/>
+              <a:t>제안하는 기법은 보다 쉬운 </a:t>
+            </a:r>
+            <a:r>
+              <a:rPr lang="ko-KR" altLang="en-US" dirty="0" err="1"/>
+              <a:t>환경임에따라</a:t>
+            </a:r>
+            <a:r>
+              <a:rPr lang="ko-KR" altLang="en-US" dirty="0"/>
+              <a:t> 보다 높은 </a:t>
+            </a:r>
+            <a:r>
+              <a:rPr lang="en-US" altLang="ko-KR" dirty="0"/>
+              <a:t>MOTA </a:t>
+            </a:r>
+            <a:r>
+              <a:rPr lang="ko-KR" altLang="en-US" dirty="0"/>
+              <a:t>기록</a:t>
+            </a:r>
+            <a:r>
+              <a:rPr lang="en-US" altLang="ko-KR" dirty="0"/>
+              <a:t>.</a:t>
+            </a:r>
+          </a:p>
+        </p:txBody>
+      </p:sp>
+      <p:sp>
+        <p:nvSpPr>
+          <p:cNvPr id="6" name="TextBox 5">
+            <a:extLst>
+              <a:ext uri="{FF2B5EF4-FFF2-40B4-BE49-F238E27FC236}">
+                <a16:creationId xmlns:a16="http://schemas.microsoft.com/office/drawing/2014/main" id="{3EA11118-CCC7-ABBD-51EE-5594F8FA5484}"/>
+              </a:ext>
+            </a:extLst>
+          </p:cNvPr>
+          <p:cNvSpPr txBox="1"/>
+          <p:nvPr/>
+        </p:nvSpPr>
+        <p:spPr>
+          <a:xfrm>
+            <a:off x="2275491" y="1266129"/>
+            <a:ext cx="1600200" cy="369332"/>
+          </a:xfrm>
+          <a:prstGeom prst="rect">
+            <a:avLst/>
+          </a:prstGeom>
+        </p:spPr>
+        <p:txBody>
+          <a:bodyPr wrap="square" rtlCol="0">
+            <a:spAutoFit/>
+          </a:bodyPr>
+          <a:lstStyle/>
+          <a:p>
+            <a:r>
+              <a:rPr lang="ko-KR" altLang="en-US" b="1" dirty="0"/>
+              <a:t>표</a:t>
+            </a:r>
+            <a:r>
+              <a:rPr lang="en-US" altLang="ko-KR" b="1" dirty="0"/>
+              <a:t>1. </a:t>
+            </a:r>
+            <a:r>
+              <a:rPr lang="ko-KR" altLang="en-US" b="1" dirty="0"/>
+              <a:t>검증결과</a:t>
+            </a:r>
+          </a:p>
+        </p:txBody>
+      </p:sp>
+      <p:graphicFrame>
+        <p:nvGraphicFramePr>
+          <p:cNvPr id="7" name="표 6">
+            <a:extLst>
+              <a:ext uri="{FF2B5EF4-FFF2-40B4-BE49-F238E27FC236}">
+                <a16:creationId xmlns:a16="http://schemas.microsoft.com/office/drawing/2014/main" id="{493B0232-B7F7-A70A-DC52-207F3E2A11B6}"/>
+              </a:ext>
+            </a:extLst>
+          </p:cNvPr>
+          <p:cNvGraphicFramePr>
+            <a:graphicFrameLocks noGrp="1"/>
+          </p:cNvGraphicFramePr>
+          <p:nvPr>
+            <p:extLst>
+              <p:ext uri="{D42A27DB-BD31-4B8C-83A1-F6EECF244321}">
+                <p14:modId xmlns:p14="http://schemas.microsoft.com/office/powerpoint/2010/main" val="1774048401"/>
+              </p:ext>
+            </p:extLst>
+          </p:nvPr>
+        </p:nvGraphicFramePr>
+        <p:xfrm>
+          <a:off x="6343905" y="1658833"/>
+          <a:ext cx="5739890" cy="1837374"/>
+        </p:xfrm>
+        <a:graphic>
+          <a:graphicData uri="http://schemas.openxmlformats.org/drawingml/2006/table">
+            <a:tbl>
+              <a:tblPr firstRow="1" bandRow="1">
+                <a:tableStyleId>{5C22544A-7EE6-4342-B048-85BDC9FD1C3A}</a:tableStyleId>
+              </a:tblPr>
+              <a:tblGrid>
+                <a:gridCol w="4226135">
+                  <a:extLst>
+                    <a:ext uri="{9D8B030D-6E8A-4147-A177-3AD203B41FA5}">
+                      <a16:colId xmlns:a16="http://schemas.microsoft.com/office/drawing/2014/main" val="1248245821"/>
+                    </a:ext>
+                  </a:extLst>
+                </a:gridCol>
+                <a:gridCol w="1513755">
+                  <a:extLst>
+                    <a:ext uri="{9D8B030D-6E8A-4147-A177-3AD203B41FA5}">
+                      <a16:colId xmlns:a16="http://schemas.microsoft.com/office/drawing/2014/main" val="1363305588"/>
+                    </a:ext>
+                  </a:extLst>
+                </a:gridCol>
+              </a:tblGrid>
+              <a:tr h="306229">
+                <a:tc>
+                  <a:txBody>
+                    <a:bodyPr/>
+                    <a:lstStyle/>
+                    <a:p>
+                      <a:pPr algn="ctr" latinLnBrk="1"/>
+                      <a:r>
+                        <a:rPr lang="ko-KR" altLang="en-US" sz="1300" dirty="0"/>
+                        <a:t>기법</a:t>
+                      </a:r>
+                    </a:p>
+                  </a:txBody>
+                  <a:tcPr/>
+                </a:tc>
+                <a:tc>
+                  <a:txBody>
+                    <a:bodyPr/>
+                    <a:lstStyle/>
+                    <a:p>
+                      <a:pPr algn="ctr" latinLnBrk="1"/>
+                      <a:r>
+                        <a:rPr lang="en-US" altLang="ko-KR" sz="1300" dirty="0"/>
+                        <a:t>MOTA</a:t>
+                      </a:r>
+                      <a:endParaRPr lang="ko-KR" altLang="en-US" sz="1300" dirty="0"/>
+                    </a:p>
+                  </a:txBody>
+                  <a:tcPr/>
+                </a:tc>
+                <a:extLst>
+                  <a:ext uri="{0D108BD9-81ED-4DB2-BD59-A6C34878D82A}">
+                    <a16:rowId xmlns:a16="http://schemas.microsoft.com/office/drawing/2014/main" val="1437392871"/>
+                  </a:ext>
+                </a:extLst>
+              </a:tr>
+              <a:tr h="306229">
+                <a:tc>
+                  <a:txBody>
+                    <a:bodyPr/>
+                    <a:lstStyle/>
+                    <a:p>
+                      <a:pPr algn="ctr" latinLnBrk="1"/>
+                      <a:r>
+                        <a:rPr lang="en-US" altLang="ko-KR" sz="1300" b="0" dirty="0" err="1"/>
+                        <a:t>MCTrack</a:t>
+                      </a:r>
+                      <a:endParaRPr lang="ko-KR" altLang="en-US" sz="1300" b="0" dirty="0"/>
+                    </a:p>
+                  </a:txBody>
+                  <a:tcPr/>
+                </a:tc>
+                <a:tc>
+                  <a:txBody>
+                    <a:bodyPr/>
+                    <a:lstStyle/>
+                    <a:p>
+                      <a:pPr algn="ctr" latinLnBrk="1"/>
+                      <a:r>
+                        <a:rPr lang="en-US" altLang="ko-KR" sz="1300" b="0" dirty="0"/>
+                        <a:t>91.62%</a:t>
+                      </a:r>
+                      <a:endParaRPr lang="ko-KR" altLang="en-US" sz="1300" b="0" dirty="0"/>
+                    </a:p>
+                  </a:txBody>
+                  <a:tcPr/>
+                </a:tc>
+                <a:extLst>
+                  <a:ext uri="{0D108BD9-81ED-4DB2-BD59-A6C34878D82A}">
+                    <a16:rowId xmlns:a16="http://schemas.microsoft.com/office/drawing/2014/main" val="3017696609"/>
+                  </a:ext>
+                </a:extLst>
+              </a:tr>
+              <a:tr h="306229">
+                <a:tc>
+                  <a:txBody>
+                    <a:bodyPr/>
+                    <a:lstStyle/>
+                    <a:p>
+                      <a:pPr algn="ctr" latinLnBrk="1"/>
+                      <a:r>
+                        <a:rPr lang="en-US" altLang="ko-KR" sz="1300" b="0" dirty="0" err="1"/>
+                        <a:t>CasTrack</a:t>
+                      </a:r>
+                      <a:endParaRPr lang="ko-KR" altLang="en-US" sz="1300" b="0" dirty="0"/>
+                    </a:p>
+                  </a:txBody>
+                  <a:tcPr/>
+                </a:tc>
+                <a:tc>
+                  <a:txBody>
+                    <a:bodyPr/>
+                    <a:lstStyle/>
+                    <a:p>
+                      <a:pPr algn="ctr" latinLnBrk="1"/>
+                      <a:r>
+                        <a:rPr lang="en-US" altLang="ko-KR" sz="1300" b="0" dirty="0"/>
+                        <a:t>91.91%</a:t>
+                      </a:r>
+                      <a:endParaRPr lang="ko-KR" altLang="en-US" sz="1300" b="0" dirty="0"/>
+                    </a:p>
+                  </a:txBody>
+                  <a:tcPr/>
+                </a:tc>
+                <a:extLst>
+                  <a:ext uri="{0D108BD9-81ED-4DB2-BD59-A6C34878D82A}">
+                    <a16:rowId xmlns:a16="http://schemas.microsoft.com/office/drawing/2014/main" val="1383321197"/>
+                  </a:ext>
+                </a:extLst>
+              </a:tr>
+              <a:tr h="306229">
+                <a:tc>
+                  <a:txBody>
+                    <a:bodyPr/>
+                    <a:lstStyle/>
+                    <a:p>
+                      <a:pPr algn="ctr" latinLnBrk="1"/>
+                      <a:r>
+                        <a:rPr lang="en-US" altLang="ko-KR" sz="1300" b="0" dirty="0"/>
+                        <a:t>RAM</a:t>
+                      </a:r>
+                      <a:endParaRPr lang="ko-KR" altLang="en-US" sz="1300" b="0" dirty="0"/>
+                    </a:p>
+                  </a:txBody>
+                  <a:tcPr/>
+                </a:tc>
+                <a:tc>
+                  <a:txBody>
+                    <a:bodyPr/>
+                    <a:lstStyle/>
+                    <a:p>
+                      <a:pPr algn="ctr" latinLnBrk="1"/>
+                      <a:r>
+                        <a:rPr lang="en-US" altLang="ko-KR" sz="1300" b="0" dirty="0"/>
+                        <a:t>91.61%</a:t>
+                      </a:r>
+                      <a:endParaRPr lang="ko-KR" altLang="en-US" sz="1300" b="0" dirty="0"/>
+                    </a:p>
+                  </a:txBody>
+                  <a:tcPr/>
+                </a:tc>
+                <a:extLst>
+                  <a:ext uri="{0D108BD9-81ED-4DB2-BD59-A6C34878D82A}">
+                    <a16:rowId xmlns:a16="http://schemas.microsoft.com/office/drawing/2014/main" val="1045870170"/>
+                  </a:ext>
+                </a:extLst>
+              </a:tr>
+              <a:tr h="306229">
+                <a:tc>
+                  <a:txBody>
+                    <a:bodyPr/>
+                    <a:lstStyle/>
+                    <a:p>
+                      <a:pPr algn="ctr" latinLnBrk="1"/>
+                      <a:r>
+                        <a:rPr lang="en-US" altLang="ko-KR" sz="1300" b="0" dirty="0"/>
+                        <a:t>OC-SORT</a:t>
+                      </a:r>
+                      <a:endParaRPr lang="ko-KR" altLang="en-US" sz="1300" b="0" dirty="0"/>
+                    </a:p>
+                  </a:txBody>
+                  <a:tcPr/>
+                </a:tc>
+                <a:tc>
+                  <a:txBody>
+                    <a:bodyPr/>
+                    <a:lstStyle/>
+                    <a:p>
+                      <a:pPr algn="ctr" latinLnBrk="1"/>
+                      <a:r>
+                        <a:rPr lang="en-US" altLang="ko-KR" sz="1300" b="0" dirty="0"/>
+                        <a:t>90.28%</a:t>
+                      </a:r>
+                      <a:endParaRPr lang="ko-KR" altLang="en-US" sz="1300" b="0" dirty="0"/>
+                    </a:p>
+                  </a:txBody>
+                  <a:tcPr/>
+                </a:tc>
+                <a:extLst>
+                  <a:ext uri="{0D108BD9-81ED-4DB2-BD59-A6C34878D82A}">
+                    <a16:rowId xmlns:a16="http://schemas.microsoft.com/office/drawing/2014/main" val="133207077"/>
+                  </a:ext>
+                </a:extLst>
+              </a:tr>
+              <a:tr h="306229">
+                <a:tc>
+                  <a:txBody>
+                    <a:bodyPr/>
+                    <a:lstStyle/>
+                    <a:p>
+                      <a:pPr algn="ctr" latinLnBrk="1"/>
+                      <a:r>
+                        <a:rPr lang="en-US" altLang="ko-KR" sz="1300" b="0" dirty="0" err="1"/>
+                        <a:t>BiTrack</a:t>
+                      </a:r>
+                      <a:endParaRPr lang="ko-KR" altLang="en-US" sz="1300" b="0" dirty="0"/>
+                    </a:p>
+                  </a:txBody>
+                  <a:tcPr/>
+                </a:tc>
+                <a:tc>
+                  <a:txBody>
+                    <a:bodyPr/>
+                    <a:lstStyle/>
+                    <a:p>
+                      <a:pPr algn="ctr" latinLnBrk="1"/>
+                      <a:r>
+                        <a:rPr lang="en-US" altLang="ko-KR" sz="1300" b="0" dirty="0"/>
+                        <a:t>91.52%</a:t>
+                      </a:r>
+                      <a:endParaRPr lang="ko-KR" altLang="en-US" sz="1300" b="0" dirty="0"/>
+                    </a:p>
+                  </a:txBody>
+                  <a:tcPr/>
+                </a:tc>
+                <a:extLst>
+                  <a:ext uri="{0D108BD9-81ED-4DB2-BD59-A6C34878D82A}">
+                    <a16:rowId xmlns:a16="http://schemas.microsoft.com/office/drawing/2014/main" val="1531617306"/>
+                  </a:ext>
+                </a:extLst>
+              </a:tr>
+            </a:tbl>
+          </a:graphicData>
+        </a:graphic>
+      </p:graphicFrame>
+      <p:sp>
+        <p:nvSpPr>
+          <p:cNvPr id="8" name="TextBox 7">
+            <a:extLst>
+              <a:ext uri="{FF2B5EF4-FFF2-40B4-BE49-F238E27FC236}">
+                <a16:creationId xmlns:a16="http://schemas.microsoft.com/office/drawing/2014/main" id="{0569836F-0DD1-A057-1FBD-AE5B82E0F968}"/>
+              </a:ext>
+            </a:extLst>
+          </p:cNvPr>
+          <p:cNvSpPr txBox="1"/>
+          <p:nvPr/>
+        </p:nvSpPr>
+        <p:spPr>
+          <a:xfrm>
+            <a:off x="7848874" y="1271074"/>
+            <a:ext cx="2755352" cy="369332"/>
+          </a:xfrm>
+          <a:prstGeom prst="rect">
+            <a:avLst/>
+          </a:prstGeom>
+        </p:spPr>
+        <p:txBody>
+          <a:bodyPr wrap="square" rtlCol="0">
+            <a:spAutoFit/>
+          </a:bodyPr>
+          <a:lstStyle/>
+          <a:p>
+            <a:pPr algn="ctr"/>
+            <a:r>
+              <a:rPr lang="ko-KR" altLang="en-US" b="1" dirty="0"/>
+              <a:t>표</a:t>
+            </a:r>
+            <a:r>
+              <a:rPr lang="en-US" altLang="ko-KR" b="1" dirty="0"/>
+              <a:t>2. </a:t>
+            </a:r>
+            <a:r>
+              <a:rPr lang="ko-KR" altLang="en-US" b="1" dirty="0"/>
+              <a:t>타 </a:t>
+            </a:r>
+            <a:r>
+              <a:rPr lang="en-US" altLang="ko-KR" b="1" dirty="0"/>
+              <a:t>Method</a:t>
+            </a:r>
+            <a:r>
+              <a:rPr lang="ko-KR" altLang="en-US" b="1" dirty="0"/>
+              <a:t> </a:t>
+            </a:r>
+            <a:r>
+              <a:rPr lang="en-US" altLang="ko-KR" b="1" dirty="0"/>
+              <a:t>MOTA</a:t>
+            </a:r>
+            <a:endParaRPr lang="ko-KR" altLang="en-US" b="1" dirty="0"/>
+          </a:p>
+        </p:txBody>
+      </p:sp>
+    </p:spTree>
+    <p:extLst>
+      <p:ext uri="{BB962C8B-B14F-4D97-AF65-F5344CB8AC3E}">
+        <p14:creationId xmlns:p14="http://schemas.microsoft.com/office/powerpoint/2010/main" val="3387734341"/>
+      </p:ext>
+    </p:extLst>
+  </p:cSld>
+  <p:clrMapOvr>
+    <a:masterClrMapping/>
+  </p:clrMapOvr>
+</p:sld>
+</file>
+
+<file path=ppt/slides/slide11.xml><?xml version="1.0" encoding="utf-8"?>
+<p:sld xmlns:a="http://schemas.openxmlformats.org/drawingml/2006/main" xmlns:r="http://schemas.openxmlformats.org/officeDocument/2006/relationships" xmlns:p="http://schemas.openxmlformats.org/presentationml/2006/main">
+  <p:cSld>
+    <p:spTree>
+      <p:nvGrpSpPr>
+        <p:cNvPr id="1" name="">
+          <a:extLst>
+            <a:ext uri="{FF2B5EF4-FFF2-40B4-BE49-F238E27FC236}">
               <a16:creationId xmlns:a16="http://schemas.microsoft.com/office/drawing/2014/main" id="{B13EE743-634B-0FF0-9F5B-FE5D53903DC7}"/>
             </a:ext>
           </a:extLst>
@@ -6756,7 +8035,7 @@
             </a:pPr>
             <a:r>
               <a:rPr lang="en-US" altLang="ko-KR" dirty="0"/>
-              <a:t>8</a:t>
+              <a:t>9</a:t>
             </a:r>
           </a:p>
         </p:txBody>
@@ -7871,7 +9150,7 @@
 </p:sld>
 </file>
 
-<file path=ppt/slides/slide11.xml><?xml version="1.0" encoding="utf-8"?>
+<file path=ppt/slides/slide12.xml><?xml version="1.0" encoding="utf-8"?>
 <p:sld xmlns:a="http://schemas.openxmlformats.org/drawingml/2006/main" xmlns:r="http://schemas.openxmlformats.org/officeDocument/2006/relationships" xmlns:p="http://schemas.openxmlformats.org/presentationml/2006/main">
   <p:cSld>
     <p:spTree>
@@ -7946,7 +9225,7 @@
             </a:pPr>
             <a:r>
               <a:rPr lang="en-US" altLang="ko-KR" dirty="0"/>
-              <a:t>9</a:t>
+              <a:t>10</a:t>
             </a:r>
           </a:p>
         </p:txBody>
@@ -8407,7 +9686,7 @@
 </p:sld>
 </file>
 
-<file path=ppt/slides/slide12.xml><?xml version="1.0" encoding="utf-8"?>
+<file path=ppt/slides/slide13.xml><?xml version="1.0" encoding="utf-8"?>
 <p:sld xmlns:a="http://schemas.openxmlformats.org/drawingml/2006/main" xmlns:r="http://schemas.openxmlformats.org/officeDocument/2006/relationships" xmlns:p="http://schemas.openxmlformats.org/presentationml/2006/main">
   <p:cSld>
     <p:spTree>
@@ -13177,8 +14456,8 @@
           </a:p>
         </p:txBody>
       </p:sp>
-      <mc:AlternateContent xmlns:mc="http://schemas.openxmlformats.org/markup-compatibility/2006" xmlns:a14="http://schemas.microsoft.com/office/drawing/2010/main">
-        <mc:Choice Requires="a14">
+      <mc:AlternateContent xmlns:mc="http://schemas.openxmlformats.org/markup-compatibility/2006">
+        <mc:Choice xmlns:a14="http://schemas.microsoft.com/office/drawing/2010/main" Requires="a14">
           <p:sp>
             <p:nvSpPr>
               <p:cNvPr id="4" name="TextBox 3">
@@ -13238,8 +14517,12 @@
                   <a:buChar char="•"/>
                 </a:pPr>
                 <a:r>
+                  <a:rPr lang="ko-KR" altLang="en-US" dirty="0"/>
+                  <a:t>수신부가</a:t>
+                </a:r>
+                <a:r>
                   <a:rPr lang="ko-KR" altLang="en-US" b="0" i="0" dirty="0"/>
-                  <a:t>타겟의 정적이므로 </a:t>
+                  <a:t> 정적이므로 </a:t>
                 </a:r>
                 <a:r>
                   <a:rPr lang="ko-KR" altLang="en-US" b="1" i="0" dirty="0"/>
@@ -13935,7 +15218,7 @@
             </p:txBody>
           </p:sp>
         </mc:Choice>
-        <mc:Fallback xmlns="">
+        <mc:Fallback>
           <p:sp>
             <p:nvSpPr>
               <p:cNvPr id="4" name="TextBox 3">
@@ -13980,8 +15263,8 @@
           </p:sp>
         </mc:Fallback>
       </mc:AlternateContent>
-      <mc:AlternateContent xmlns:mc="http://schemas.openxmlformats.org/markup-compatibility/2006">
-        <mc:Choice xmlns:a14="http://schemas.microsoft.com/office/drawing/2010/main" Requires="a14">
+      <mc:AlternateContent xmlns:mc="http://schemas.openxmlformats.org/markup-compatibility/2006" xmlns:a14="http://schemas.microsoft.com/office/drawing/2010/main">
+        <mc:Choice Requires="a14">
           <p:graphicFrame>
             <p:nvGraphicFramePr>
               <p:cNvPr id="18" name="표 17">
@@ -14753,7 +16036,7 @@
             </a:graphic>
           </p:graphicFrame>
         </mc:Choice>
-        <mc:Fallback>
+        <mc:Fallback xmlns="">
           <p:graphicFrame>
             <p:nvGraphicFramePr>
               <p:cNvPr id="18" name="표 17">
@@ -21040,8 +22323,8 @@
           </a:p>
         </p:txBody>
       </p:sp>
-      <mc:AlternateContent xmlns:mc="http://schemas.openxmlformats.org/markup-compatibility/2006">
-        <mc:Choice xmlns:a14="http://schemas.microsoft.com/office/drawing/2010/main" Requires="a14">
+      <mc:AlternateContent xmlns:mc="http://schemas.openxmlformats.org/markup-compatibility/2006" xmlns:a14="http://schemas.microsoft.com/office/drawing/2010/main">
+        <mc:Choice Requires="a14">
           <p:sp>
             <p:nvSpPr>
               <p:cNvPr id="14" name="TextBox 13">
@@ -21516,7 +22799,7 @@
             </p:txBody>
           </p:sp>
         </mc:Choice>
-        <mc:Fallback>
+        <mc:Fallback xmlns="">
           <p:sp>
             <p:nvSpPr>
               <p:cNvPr id="14" name="TextBox 13">
@@ -21616,7 +22899,7 @@
         <p:cNvPr id="1" name="">
           <a:extLst>
             <a:ext uri="{FF2B5EF4-FFF2-40B4-BE49-F238E27FC236}">
-              <a16:creationId xmlns:a16="http://schemas.microsoft.com/office/drawing/2014/main" id="{F6935EE4-9FA8-A41A-FDE5-23286AA1C52D}"/>
+              <a16:creationId xmlns:a16="http://schemas.microsoft.com/office/drawing/2014/main" id="{500D09C7-06EC-27F3-F896-C9B3C1FD31B8}"/>
             </a:ext>
           </a:extLst>
         </p:cNvPr>
@@ -21633,10 +22916,10 @@
       </p:grpSpPr>
       <p:sp>
         <p:nvSpPr>
-          <p:cNvPr id="11" name="직사각형 10">
+          <p:cNvPr id="12" name="직사각형 11">
             <a:extLst>
               <a:ext uri="{FF2B5EF4-FFF2-40B4-BE49-F238E27FC236}">
-                <a16:creationId xmlns:a16="http://schemas.microsoft.com/office/drawing/2014/main" id="{350AC225-BD28-A372-8F78-98DB416A587E}"/>
+                <a16:creationId xmlns:a16="http://schemas.microsoft.com/office/drawing/2014/main" id="{F8ADD922-D657-D248-F11A-DD099E32ABF3}"/>
               </a:ext>
             </a:extLst>
           </p:cNvPr>
@@ -21645,93 +22928,8 @@
         </p:nvSpPr>
         <p:spPr>
           <a:xfrm>
-            <a:off x="0" y="6536360"/>
-            <a:ext cx="12192000" cy="323240"/>
-          </a:xfrm>
-          <a:prstGeom prst="rect">
-            <a:avLst/>
-          </a:prstGeom>
-          <a:solidFill>
-            <a:srgbClr val="5894CF"/>
-          </a:solidFill>
-          <a:ln>
-            <a:noFill/>
-          </a:ln>
-        </p:spPr>
-        <p:style>
-          <a:lnRef idx="2">
-            <a:schemeClr val="accent1">
-              <a:shade val="15000"/>
-            </a:schemeClr>
-          </a:lnRef>
-          <a:fillRef idx="1">
-            <a:schemeClr val="accent1"/>
-          </a:fillRef>
-          <a:effectRef idx="0">
-            <a:schemeClr val="accent1"/>
-          </a:effectRef>
-          <a:fontRef idx="minor">
-            <a:schemeClr val="lt1"/>
-          </a:fontRef>
-        </p:style>
-        <p:txBody>
-          <a:bodyPr anchor="ctr"/>
-          <a:lstStyle/>
-          <a:p>
-            <a:pPr lvl="0">
-              <a:defRPr/>
-            </a:pPr>
-            <a:r>
-              <a:rPr lang="en-US" altLang="ko-KR" sz="800" dirty="0"/>
-              <a:t>[5] X. Wang </a:t>
-            </a:r>
-            <a:r>
-              <a:rPr lang="en-US" altLang="ko-KR" sz="800" i="1" dirty="0"/>
-              <a:t>et al</a:t>
-            </a:r>
-            <a:r>
-              <a:rPr lang="en-US" altLang="ko-KR" sz="800" dirty="0"/>
-              <a:t>., "</a:t>
-            </a:r>
-            <a:r>
-              <a:rPr lang="en-US" altLang="ko-KR" sz="800" dirty="0" err="1"/>
-              <a:t>MCTrack</a:t>
-            </a:r>
-            <a:r>
-              <a:rPr lang="en-US" altLang="ko-KR" sz="800" dirty="0"/>
-              <a:t>: A Unified 3D Multi-Object Tracking Framework for Autonomous Driving," </a:t>
-            </a:r>
-            <a:r>
-              <a:rPr lang="en-US" altLang="ko-KR" sz="800" i="1" dirty="0"/>
-              <a:t>2025 IEEE/RSJ International Conference on Intelligent Robots and Systems (IROS)</a:t>
-            </a:r>
-            <a:r>
-              <a:rPr lang="en-US" altLang="ko-KR" sz="800" dirty="0"/>
-              <a:t>, Hangzhou, China, 2025                                                           </a:t>
-            </a:r>
-            <a:r>
-              <a:rPr lang="en-US" altLang="ko-KR" dirty="0"/>
-              <a:t>7</a:t>
-            </a:r>
-          </a:p>
-        </p:txBody>
-      </p:sp>
-      <p:sp>
-        <p:nvSpPr>
-          <p:cNvPr id="12" name="직사각형 11">
-            <a:extLst>
-              <a:ext uri="{FF2B5EF4-FFF2-40B4-BE49-F238E27FC236}">
-                <a16:creationId xmlns:a16="http://schemas.microsoft.com/office/drawing/2014/main" id="{9FC5284B-96D8-ED3C-F1C5-146E487D93FB}"/>
-              </a:ext>
-            </a:extLst>
-          </p:cNvPr>
-          <p:cNvSpPr/>
-          <p:nvPr/>
-        </p:nvSpPr>
-        <p:spPr>
-          <a:xfrm>
-            <a:off x="-7882" y="0"/>
-            <a:ext cx="12230704" cy="6537960"/>
+            <a:off x="0" y="0"/>
+            <a:ext cx="12192000" cy="6530746"/>
           </a:xfrm>
           <a:prstGeom prst="rect">
             <a:avLst/>
@@ -21757,18 +22955,16 @@
           </a:fontRef>
         </p:style>
         <p:txBody>
-          <a:bodyPr anchor="ctr"/>
+          <a:bodyPr numCol="1" rtlCol="0" anchor="ctr"/>
           <a:lstStyle/>
           <a:p>
-            <a:pPr lvl="0" algn="ctr">
-              <a:defRPr/>
-            </a:pPr>
+            <a:pPr algn="ctr"/>
             <a:endParaRPr lang="en-US" altLang="ko-KR" dirty="0">
               <a:solidFill>
                 <a:schemeClr val="tx1"/>
               </a:solidFill>
-              <a:latin typeface="HY헤드라인M"/>
-              <a:ea typeface="HY헤드라인M"/>
+              <a:latin typeface="HY헤드라인M" panose="02030600000101010101" pitchFamily="18" charset="-127"/>
+              <a:ea typeface="HY헤드라인M" panose="02030600000101010101" pitchFamily="18" charset="-127"/>
             </a:endParaRPr>
           </a:p>
         </p:txBody>
@@ -21778,7 +22974,7 @@
           <p:cNvPr id="16" name="직사각형 15">
             <a:extLst>
               <a:ext uri="{FF2B5EF4-FFF2-40B4-BE49-F238E27FC236}">
-                <a16:creationId xmlns:a16="http://schemas.microsoft.com/office/drawing/2014/main" id="{23117118-068C-1061-FEB3-0573061E3184}"/>
+                <a16:creationId xmlns:a16="http://schemas.microsoft.com/office/drawing/2014/main" id="{ADB37563-E2E8-8652-33CC-A36D6E01A943}"/>
               </a:ext>
             </a:extLst>
           </p:cNvPr>
@@ -21817,12 +23013,10 @@
           </a:fontRef>
         </p:style>
         <p:txBody>
-          <a:bodyPr anchor="ctr"/>
+          <a:bodyPr rtlCol="0" anchor="ctr"/>
           <a:lstStyle/>
           <a:p>
-            <a:pPr lvl="0" algn="ctr">
-              <a:defRPr/>
-            </a:pPr>
+            <a:pPr algn="ctr"/>
             <a:endParaRPr lang="ko-KR" altLang="en-US"/>
           </a:p>
         </p:txBody>
@@ -21832,7 +23026,7 @@
           <p:cNvPr id="15" name="직사각형 14">
             <a:extLst>
               <a:ext uri="{FF2B5EF4-FFF2-40B4-BE49-F238E27FC236}">
-                <a16:creationId xmlns:a16="http://schemas.microsoft.com/office/drawing/2014/main" id="{40D5AABD-7ED9-FCA1-3D7E-A80F1136E2EC}"/>
+                <a16:creationId xmlns:a16="http://schemas.microsoft.com/office/drawing/2014/main" id="{3C28E054-15FA-F738-7A9C-35F11702949B}"/>
               </a:ext>
             </a:extLst>
           </p:cNvPr>
@@ -21871,348 +23065,73 @@
           </a:fontRef>
         </p:style>
         <p:txBody>
-          <a:bodyPr anchor="ctr"/>
+          <a:bodyPr rtlCol="0" anchor="ctr"/>
           <a:lstStyle/>
           <a:p>
-            <a:pPr lvl="0" algn="ctr">
-              <a:defRPr/>
-            </a:pPr>
+            <a:pPr algn="ctr"/>
             <a:r>
               <a:rPr lang="ko-KR" altLang="en-US" dirty="0">
                 <a:solidFill>
                   <a:schemeClr val="tx1"/>
                 </a:solidFill>
-                <a:latin typeface="HY헤드라인M"/>
-                <a:ea typeface="HY헤드라인M"/>
+                <a:latin typeface="HY헤드라인M" panose="02030600000101010101" pitchFamily="18" charset="-127"/>
+                <a:ea typeface="HY헤드라인M" panose="02030600000101010101" pitchFamily="18" charset="-127"/>
               </a:rPr>
-              <a:t>성능 평가</a:t>
-            </a:r>
-            <a:endParaRPr lang="en-US" altLang="ko-KR" dirty="0">
-              <a:solidFill>
-                <a:schemeClr val="tx1"/>
-              </a:solidFill>
-              <a:latin typeface="HY헤드라인M"/>
-              <a:ea typeface="HY헤드라인M"/>
-            </a:endParaRPr>
+              <a:t>성능평가</a:t>
+            </a:r>
           </a:p>
         </p:txBody>
       </p:sp>
-      <p:graphicFrame>
-        <p:nvGraphicFramePr>
-          <p:cNvPr id="2" name="표 1">
+      <p:sp>
+        <p:nvSpPr>
+          <p:cNvPr id="4" name="TextBox 3">
             <a:extLst>
               <a:ext uri="{FF2B5EF4-FFF2-40B4-BE49-F238E27FC236}">
-                <a16:creationId xmlns:a16="http://schemas.microsoft.com/office/drawing/2014/main" id="{C071F9A1-9B27-6ADE-31A5-C8FF5C811BDE}"/>
+                <a16:creationId xmlns:a16="http://schemas.microsoft.com/office/drawing/2014/main" id="{0E19785C-40D0-1EB0-3FC0-3DF2BB3131CA}"/>
               </a:ext>
             </a:extLst>
           </p:cNvPr>
-          <p:cNvGraphicFramePr>
-            <a:graphicFrameLocks noGrp="1"/>
-          </p:cNvGraphicFramePr>
-          <p:nvPr>
-            <p:extLst>
-              <p:ext uri="{D42A27DB-BD31-4B8C-83A1-F6EECF244321}">
-                <p14:modId xmlns:p14="http://schemas.microsoft.com/office/powerpoint/2010/main" val="1959343741"/>
-              </p:ext>
-            </p:extLst>
-          </p:nvPr>
-        </p:nvGraphicFramePr>
-        <p:xfrm>
-          <a:off x="368555" y="1658833"/>
-          <a:ext cx="5739890" cy="1837374"/>
-        </p:xfrm>
-        <a:graphic>
-          <a:graphicData uri="http://schemas.openxmlformats.org/drawingml/2006/table">
-            <a:tbl>
-              <a:tblPr firstRow="1" bandRow="1">
-                <a:tableStyleId>{5C22544A-7EE6-4342-B048-85BDC9FD1C3A}</a:tableStyleId>
-              </a:tblPr>
-              <a:tblGrid>
-                <a:gridCol w="4226135">
-                  <a:extLst>
-                    <a:ext uri="{9D8B030D-6E8A-4147-A177-3AD203B41FA5}">
-                      <a16:colId xmlns:a16="http://schemas.microsoft.com/office/drawing/2014/main" val="1248245821"/>
-                    </a:ext>
-                  </a:extLst>
-                </a:gridCol>
-                <a:gridCol w="1513755">
-                  <a:extLst>
-                    <a:ext uri="{9D8B030D-6E8A-4147-A177-3AD203B41FA5}">
-                      <a16:colId xmlns:a16="http://schemas.microsoft.com/office/drawing/2014/main" val="1363305588"/>
-                    </a:ext>
-                  </a:extLst>
-                </a:gridCol>
-              </a:tblGrid>
-              <a:tr h="306229">
-                <a:tc>
-                  <a:txBody>
-                    <a:bodyPr/>
-                    <a:lstStyle/>
-                    <a:p>
-                      <a:pPr algn="ctr" latinLnBrk="1"/>
-                      <a:r>
-                        <a:rPr lang="ko-KR" altLang="en-US" sz="1300" dirty="0"/>
-                        <a:t>파라미터</a:t>
-                      </a:r>
-                    </a:p>
-                  </a:txBody>
-                  <a:tcPr/>
-                </a:tc>
-                <a:tc>
-                  <a:txBody>
-                    <a:bodyPr/>
-                    <a:lstStyle/>
-                    <a:p>
-                      <a:pPr algn="ctr" latinLnBrk="1"/>
-                      <a:r>
-                        <a:rPr lang="ko-KR" altLang="en-US" sz="1300"/>
-                        <a:t>값</a:t>
-                      </a:r>
-                      <a:endParaRPr lang="ko-KR" altLang="en-US" sz="1300" dirty="0"/>
-                    </a:p>
-                  </a:txBody>
-                  <a:tcPr/>
-                </a:tc>
-                <a:extLst>
-                  <a:ext uri="{0D108BD9-81ED-4DB2-BD59-A6C34878D82A}">
-                    <a16:rowId xmlns:a16="http://schemas.microsoft.com/office/drawing/2014/main" val="1437392871"/>
-                  </a:ext>
-                </a:extLst>
-              </a:tr>
-              <a:tr h="306229">
-                <a:tc>
-                  <a:txBody>
-                    <a:bodyPr/>
-                    <a:lstStyle/>
-                    <a:p>
-                      <a:pPr algn="ctr" latinLnBrk="1"/>
-                      <a:r>
-                        <a:rPr lang="ko-KR" altLang="en-US" sz="1300" b="0" dirty="0"/>
-                        <a:t>실제 타겟 수</a:t>
-                      </a:r>
-                    </a:p>
-                  </a:txBody>
-                  <a:tcPr/>
-                </a:tc>
-                <a:tc>
-                  <a:txBody>
-                    <a:bodyPr/>
-                    <a:lstStyle/>
-                    <a:p>
-                      <a:pPr algn="ctr" latinLnBrk="1"/>
-                      <a:r>
-                        <a:rPr lang="en-US" altLang="ko-KR" sz="1300" b="0" dirty="0"/>
-                        <a:t>4 </a:t>
-                      </a:r>
-                      <a:r>
-                        <a:rPr lang="ko-KR" altLang="en-US" sz="1300" b="0" dirty="0"/>
-                        <a:t>개</a:t>
-                      </a:r>
-                    </a:p>
-                  </a:txBody>
-                  <a:tcPr/>
-                </a:tc>
-                <a:extLst>
-                  <a:ext uri="{0D108BD9-81ED-4DB2-BD59-A6C34878D82A}">
-                    <a16:rowId xmlns:a16="http://schemas.microsoft.com/office/drawing/2014/main" val="3017696609"/>
-                  </a:ext>
-                </a:extLst>
-              </a:tr>
-              <a:tr h="306229">
-                <a:tc>
-                  <a:txBody>
-                    <a:bodyPr/>
-                    <a:lstStyle/>
-                    <a:p>
-                      <a:pPr algn="ctr" latinLnBrk="1"/>
-                      <a:r>
-                        <a:rPr lang="ko-KR" altLang="en-US" sz="1300" b="0" dirty="0"/>
-                        <a:t>식별 타겟 수</a:t>
-                      </a:r>
-                    </a:p>
-                  </a:txBody>
-                  <a:tcPr/>
-                </a:tc>
-                <a:tc>
-                  <a:txBody>
-                    <a:bodyPr/>
-                    <a:lstStyle/>
-                    <a:p>
-                      <a:pPr algn="ctr" latinLnBrk="1"/>
-                      <a:r>
-                        <a:rPr lang="en-US" altLang="ko-KR" sz="1300" b="0" dirty="0"/>
-                        <a:t>10 </a:t>
-                      </a:r>
-                      <a:r>
-                        <a:rPr lang="ko-KR" altLang="en-US" sz="1300" b="0" dirty="0"/>
-                        <a:t>개</a:t>
-                      </a:r>
-                    </a:p>
-                  </a:txBody>
-                  <a:tcPr/>
-                </a:tc>
-                <a:extLst>
-                  <a:ext uri="{0D108BD9-81ED-4DB2-BD59-A6C34878D82A}">
-                    <a16:rowId xmlns:a16="http://schemas.microsoft.com/office/drawing/2014/main" val="1383321197"/>
-                  </a:ext>
-                </a:extLst>
-              </a:tr>
-              <a:tr h="306229">
-                <a:tc>
-                  <a:txBody>
-                    <a:bodyPr/>
-                    <a:lstStyle/>
-                    <a:p>
-                      <a:pPr algn="ctr" latinLnBrk="1"/>
-                      <a:r>
-                        <a:rPr lang="en-US" altLang="ko-KR" sz="1300" b="0" dirty="0"/>
-                        <a:t>MOTA(</a:t>
-                      </a:r>
-                      <a:r>
-                        <a:rPr lang="ko-KR" altLang="en-US" sz="1300" b="0" dirty="0"/>
-                        <a:t>↑</a:t>
-                      </a:r>
-                      <a:r>
-                        <a:rPr lang="en-US" altLang="ko-KR" sz="1300" b="0" dirty="0"/>
-                        <a:t>)</a:t>
-                      </a:r>
-                      <a:endParaRPr lang="ko-KR" altLang="en-US" sz="1300" b="0" dirty="0"/>
-                    </a:p>
-                  </a:txBody>
-                  <a:tcPr/>
-                </a:tc>
-                <a:tc>
-                  <a:txBody>
-                    <a:bodyPr/>
-                    <a:lstStyle/>
-                    <a:p>
-                      <a:pPr algn="ctr" latinLnBrk="1"/>
-                      <a:r>
-                        <a:rPr lang="en-US" altLang="ko-KR" sz="1300" b="0" dirty="0"/>
-                        <a:t>94.5%</a:t>
-                      </a:r>
-                      <a:endParaRPr lang="ko-KR" altLang="en-US" sz="1300" b="0" dirty="0"/>
-                    </a:p>
-                  </a:txBody>
-                  <a:tcPr/>
-                </a:tc>
-                <a:extLst>
-                  <a:ext uri="{0D108BD9-81ED-4DB2-BD59-A6C34878D82A}">
-                    <a16:rowId xmlns:a16="http://schemas.microsoft.com/office/drawing/2014/main" val="1045870170"/>
-                  </a:ext>
-                </a:extLst>
-              </a:tr>
-              <a:tr h="306229">
-                <a:tc>
-                  <a:txBody>
-                    <a:bodyPr/>
-                    <a:lstStyle/>
-                    <a:p>
-                      <a:pPr algn="ctr" latinLnBrk="1"/>
-                      <a:r>
-                        <a:rPr lang="en-US" altLang="ko-KR" sz="1300" b="0" dirty="0"/>
-                        <a:t>IDSW(</a:t>
-                      </a:r>
-                      <a:r>
-                        <a:rPr lang="ko-KR" altLang="en-US" sz="1300" b="0" dirty="0"/>
-                        <a:t>↓</a:t>
-                      </a:r>
-                      <a:r>
-                        <a:rPr lang="en-US" altLang="ko-KR" sz="1300" b="0" dirty="0"/>
-                        <a:t>)</a:t>
-                      </a:r>
-                      <a:endParaRPr lang="ko-KR" altLang="en-US" sz="1300" b="0" dirty="0"/>
-                    </a:p>
-                  </a:txBody>
-                  <a:tcPr/>
-                </a:tc>
-                <a:tc>
-                  <a:txBody>
-                    <a:bodyPr/>
-                    <a:lstStyle/>
-                    <a:p>
-                      <a:pPr algn="ctr" latinLnBrk="1"/>
-                      <a:r>
-                        <a:rPr lang="en-US" altLang="ko-KR" sz="1300" b="0" dirty="0"/>
-                        <a:t>6</a:t>
-                      </a:r>
-                      <a:r>
-                        <a:rPr lang="ko-KR" altLang="en-US" sz="1300" b="0" dirty="0"/>
-                        <a:t>회</a:t>
-                      </a:r>
-                    </a:p>
-                  </a:txBody>
-                  <a:tcPr/>
-                </a:tc>
-                <a:extLst>
-                  <a:ext uri="{0D108BD9-81ED-4DB2-BD59-A6C34878D82A}">
-                    <a16:rowId xmlns:a16="http://schemas.microsoft.com/office/drawing/2014/main" val="133207077"/>
-                  </a:ext>
-                </a:extLst>
-              </a:tr>
-              <a:tr h="306229">
-                <a:tc>
-                  <a:txBody>
-                    <a:bodyPr/>
-                    <a:lstStyle/>
-                    <a:p>
-                      <a:pPr algn="ctr" latinLnBrk="1"/>
-                      <a:r>
-                        <a:rPr lang="en-US" altLang="ko-KR" sz="1300" b="0" dirty="0"/>
-                        <a:t>ID</a:t>
-                      </a:r>
-                      <a:r>
-                        <a:rPr lang="ko-KR" altLang="en-US" sz="1300" b="0" dirty="0"/>
-                        <a:t> </a:t>
-                      </a:r>
-                      <a:r>
-                        <a:rPr lang="en-US" altLang="ko-KR" sz="1300" b="0" dirty="0"/>
-                        <a:t>Purity(</a:t>
-                      </a:r>
-                      <a:r>
-                        <a:rPr lang="ko-KR" altLang="en-US" sz="1300" b="0" dirty="0"/>
-                        <a:t>↑</a:t>
-                      </a:r>
-                      <a:r>
-                        <a:rPr lang="en-US" altLang="ko-KR" sz="1300" b="0" dirty="0"/>
-                        <a:t>)</a:t>
-                      </a:r>
-                      <a:endParaRPr lang="ko-KR" altLang="en-US" sz="1300" b="0" dirty="0"/>
-                    </a:p>
-                  </a:txBody>
-                  <a:tcPr/>
-                </a:tc>
-                <a:tc>
-                  <a:txBody>
-                    <a:bodyPr/>
-                    <a:lstStyle/>
-                    <a:p>
-                      <a:pPr algn="ctr" latinLnBrk="1"/>
-                      <a:r>
-                        <a:rPr lang="en-US" altLang="ko-KR" sz="1300" b="0" dirty="0"/>
-                        <a:t>100%</a:t>
-                      </a:r>
-                      <a:endParaRPr lang="ko-KR" altLang="en-US" sz="1300" b="0" dirty="0"/>
-                    </a:p>
-                  </a:txBody>
-                  <a:tcPr/>
-                </a:tc>
-                <a:extLst>
-                  <a:ext uri="{0D108BD9-81ED-4DB2-BD59-A6C34878D82A}">
-                    <a16:rowId xmlns:a16="http://schemas.microsoft.com/office/drawing/2014/main" val="1531617306"/>
-                  </a:ext>
-                </a:extLst>
-              </a:tr>
-            </a:tbl>
-          </a:graphicData>
-        </a:graphic>
-      </p:graphicFrame>
+          <p:cNvSpPr txBox="1"/>
+          <p:nvPr/>
+        </p:nvSpPr>
+        <p:spPr>
+          <a:xfrm>
+            <a:off x="11893721" y="6506100"/>
+            <a:ext cx="259644" cy="369332"/>
+          </a:xfrm>
+          <a:prstGeom prst="rect">
+            <a:avLst/>
+          </a:prstGeom>
+          <a:noFill/>
+        </p:spPr>
+        <p:txBody>
+          <a:bodyPr wrap="square" rtlCol="0">
+            <a:spAutoFit/>
+          </a:bodyPr>
+          <a:lstStyle/>
+          <a:p>
+            <a:r>
+              <a:rPr lang="en-US" altLang="ko-KR" dirty="0">
+                <a:solidFill>
+                  <a:schemeClr val="bg1"/>
+                </a:solidFill>
+              </a:rPr>
+              <a:t>1</a:t>
+            </a:r>
+            <a:endParaRPr lang="ko-KR" altLang="en-US" dirty="0">
+              <a:solidFill>
+                <a:schemeClr val="bg1"/>
+              </a:solidFill>
+            </a:endParaRPr>
+          </a:p>
+        </p:txBody>
+      </p:sp>
       <p:sp>
         <p:nvSpPr>
-          <p:cNvPr id="3" name="TextBox 2">
+          <p:cNvPr id="5" name="TextBox 4">
             <a:extLst>
               <a:ext uri="{FF2B5EF4-FFF2-40B4-BE49-F238E27FC236}">
-                <a16:creationId xmlns:a16="http://schemas.microsoft.com/office/drawing/2014/main" id="{1823AAD7-B6FC-EB0A-B77C-6BA4E6C84CCE}"/>
+                <a16:creationId xmlns:a16="http://schemas.microsoft.com/office/drawing/2014/main" id="{7415DEDD-46EB-5CBD-A033-BADF7C1D77D1}"/>
               </a:ext>
             </a:extLst>
           </p:cNvPr>
@@ -22237,7 +23156,64 @@
           <a:p>
             <a:r>
               <a:rPr lang="ko-KR" altLang="en-US" sz="2400" b="1" dirty="0"/>
-              <a:t>  ■ 검증 결과</a:t>
+              <a:t>  ■ 평가지표</a:t>
+            </a:r>
+          </a:p>
+        </p:txBody>
+      </p:sp>
+      <p:sp>
+        <p:nvSpPr>
+          <p:cNvPr id="6" name="직사각형 5">
+            <a:extLst>
+              <a:ext uri="{FF2B5EF4-FFF2-40B4-BE49-F238E27FC236}">
+                <a16:creationId xmlns:a16="http://schemas.microsoft.com/office/drawing/2014/main" id="{A6A98C5A-7D55-D38A-1196-19A641D13D1C}"/>
+              </a:ext>
+            </a:extLst>
+          </p:cNvPr>
+          <p:cNvSpPr/>
+          <p:nvPr/>
+        </p:nvSpPr>
+        <p:spPr>
+          <a:xfrm>
+            <a:off x="0" y="6537960"/>
+            <a:ext cx="12192000" cy="320040"/>
+          </a:xfrm>
+          <a:prstGeom prst="rect">
+            <a:avLst/>
+          </a:prstGeom>
+          <a:solidFill>
+            <a:srgbClr val="5894CF"/>
+          </a:solidFill>
+          <a:ln>
+            <a:noFill/>
+          </a:ln>
+        </p:spPr>
+        <p:style>
+          <a:lnRef idx="2">
+            <a:schemeClr val="accent1">
+              <a:shade val="15000"/>
+            </a:schemeClr>
+          </a:lnRef>
+          <a:fillRef idx="1">
+            <a:schemeClr val="accent1"/>
+          </a:fillRef>
+          <a:effectRef idx="0">
+            <a:schemeClr val="accent1"/>
+          </a:effectRef>
+          <a:fontRef idx="minor">
+            <a:schemeClr val="lt1"/>
+          </a:fontRef>
+        </p:style>
+        <p:txBody>
+          <a:bodyPr anchor="ctr"/>
+          <a:lstStyle/>
+          <a:p>
+            <a:pPr lvl="0" algn="r">
+              <a:defRPr/>
+            </a:pPr>
+            <a:r>
+              <a:rPr lang="en-US" altLang="ko-KR" dirty="0"/>
+              <a:t>7           </a:t>
             </a:r>
           </a:p>
         </p:txBody>
@@ -22246,10 +23222,10 @@
         <mc:Choice xmlns:a14="http://schemas.microsoft.com/office/drawing/2010/main" Requires="a14">
           <p:sp>
             <p:nvSpPr>
-              <p:cNvPr id="4" name="TextBox 3">
+              <p:cNvPr id="7" name="TextBox 6">
                 <a:extLst>
                   <a:ext uri="{FF2B5EF4-FFF2-40B4-BE49-F238E27FC236}">
-                    <a16:creationId xmlns:a16="http://schemas.microsoft.com/office/drawing/2014/main" id="{4131AD9A-0C01-EF4A-EC54-56F0CDCAB555}"/>
+                    <a16:creationId xmlns:a16="http://schemas.microsoft.com/office/drawing/2014/main" id="{CB7D23DC-E6AC-6A9E-6D7E-04667438039F}"/>
                   </a:ext>
                 </a:extLst>
               </p:cNvPr>
@@ -22258,8 +23234,8 @@
             </p:nvSpPr>
             <p:spPr>
               <a:xfrm>
-                <a:off x="305274" y="4061895"/>
-                <a:ext cx="8019576" cy="1382366"/>
+                <a:off x="369115" y="1442335"/>
+                <a:ext cx="11563241" cy="3988143"/>
               </a:xfrm>
               <a:prstGeom prst="rect">
                 <a:avLst/>
@@ -22277,86 +23253,151 @@
                   <a:buChar char="•"/>
                 </a:pPr>
                 <a:r>
-                  <a:rPr lang="ko-KR" altLang="en-US" b="0" i="0" dirty="0">
-                    <a:latin typeface="Cambria Math" panose="02040503050406030204" pitchFamily="18" charset="0"/>
-                  </a:rPr>
-                  <a:t>실내 환경에서 </a:t>
+                  <a:rPr lang="en-US" altLang="ko-KR" sz="2000" b="1" dirty="0"/>
+                  <a:t>IDSW(ID</a:t>
                 </a:r>
                 <a:r>
-                  <a:rPr lang="en-US" altLang="ko-KR" b="0" i="0" dirty="0">
-                    <a:latin typeface="Cambria Math" panose="02040503050406030204" pitchFamily="18" charset="0"/>
-                  </a:rPr>
-                  <a:t>5-10m </a:t>
+                  <a:rPr lang="ko-KR" altLang="en-US" sz="2000" b="1" dirty="0"/>
+                  <a:t> </a:t>
                 </a:r>
                 <a:r>
-                  <a:rPr lang="ko-KR" altLang="en-US" b="0" i="0" dirty="0">
-                    <a:latin typeface="Cambria Math" panose="02040503050406030204" pitchFamily="18" charset="0"/>
-                  </a:rPr>
-                  <a:t>거리에 수신부를 배치하여 획득한 데이터 셋 활용</a:t>
+                  <a:rPr lang="en-US" altLang="ko-KR" sz="2000" b="1" dirty="0"/>
+                  <a:t>Switch)</a:t>
+                </a:r>
+                <a:br>
+                  <a:rPr lang="en-US" altLang="ko-KR" sz="2000" b="1" dirty="0"/>
+                </a:br>
+                <a:r>
+                  <a:rPr lang="en-US" altLang="ko-KR" sz="2000" b="1" dirty="0"/>
+                  <a:t>-  </a:t>
                 </a:r>
                 <a:r>
-                  <a:rPr lang="en-US" altLang="ko-KR" b="0" i="0" dirty="0">
-                    <a:latin typeface="Cambria Math" panose="02040503050406030204" pitchFamily="18" charset="0"/>
-                  </a:rPr>
-                  <a:t>.</a:t>
+                  <a:rPr lang="ko-KR" altLang="en-US" sz="2000" dirty="0"/>
+                  <a:t>추적하는 타겟의 </a:t>
                 </a:r>
+                <a:r>
+                  <a:rPr lang="en-US" altLang="ko-KR" sz="2000" dirty="0"/>
+                  <a:t>ID</a:t>
+                </a:r>
+                <a:r>
+                  <a:rPr lang="ko-KR" altLang="en-US" sz="2000" dirty="0"/>
+                  <a:t>가 바뀌는 횟수</a:t>
+                </a:r>
+                <a:endParaRPr lang="en-US" altLang="ko-KR" sz="2000" dirty="0"/>
               </a:p>
               <a:p>
                 <a:pPr marL="285750" indent="-285750">
                   <a:buFont typeface="Arial" panose="020B0604020202020204" pitchFamily="34" charset="0"/>
                   <a:buChar char="•"/>
                 </a:pPr>
+                <a:endParaRPr lang="en-US" altLang="ko-KR" sz="2000" b="1" dirty="0"/>
+              </a:p>
+              <a:p>
+                <a:pPr marL="285750" indent="-285750">
+                  <a:buFont typeface="Arial" panose="020B0604020202020204" pitchFamily="34" charset="0"/>
+                  <a:buChar char="•"/>
+                </a:pPr>
+                <a:r>
+                  <a:rPr lang="en-US" altLang="ko-KR" sz="2000" b="1" dirty="0"/>
+                  <a:t>ID Purity</a:t>
+                </a:r>
+                <a:br>
+                  <a:rPr lang="en-US" altLang="ko-KR" sz="2000" b="1" dirty="0"/>
+                </a:br>
+                <a:r>
+                  <a:rPr lang="en-US" altLang="ko-KR" sz="2000" b="1" dirty="0"/>
+                  <a:t>- </a:t>
+                </a:r>
+                <a:r>
+                  <a:rPr lang="ko-KR" altLang="en-US" sz="2000" dirty="0"/>
+                  <a:t>하나의 </a:t>
+                </a:r>
+                <a:r>
+                  <a:rPr lang="en-US" altLang="ko-KR" sz="2000" dirty="0"/>
+                  <a:t>ID</a:t>
+                </a:r>
+                <a:r>
+                  <a:rPr lang="ko-KR" altLang="en-US" sz="2000" dirty="0"/>
+                  <a:t>에서 가장 많은 빈도의 타겟이 차지하는 비율</a:t>
+                </a:r>
+                <a:endParaRPr lang="en-US" altLang="ko-KR" sz="2000" dirty="0"/>
+              </a:p>
+              <a:p>
+                <a:pPr marL="285750" indent="-285750">
+                  <a:buFont typeface="Arial" panose="020B0604020202020204" pitchFamily="34" charset="0"/>
+                  <a:buChar char="•"/>
+                </a:pPr>
+                <a:endParaRPr lang="en-US" altLang="ko-KR" sz="2000" b="1" dirty="0"/>
+              </a:p>
+              <a:p>
+                <a:pPr marL="285750" indent="-285750">
+                  <a:buFont typeface="Arial" panose="020B0604020202020204" pitchFamily="34" charset="0"/>
+                  <a:buChar char="•"/>
+                </a:pPr>
+                <a:r>
+                  <a:rPr lang="en-US" altLang="ko-KR" sz="2000" b="1" dirty="0"/>
+                  <a:t>MOTA(MOT Accuracy)</a:t>
+                </a:r>
+                <a:br>
+                  <a:rPr lang="en-US" altLang="ko-KR" sz="2000" b="1" dirty="0"/>
+                </a:br>
+                <a:r>
+                  <a:rPr lang="en-US" altLang="ko-KR" sz="2000" b="1" dirty="0"/>
+                  <a:t>- </a:t>
+                </a:r>
+                <a:r>
+                  <a:rPr lang="ko-KR" altLang="en-US" sz="2000" dirty="0"/>
+                  <a:t>탐지성능과 </a:t>
+                </a:r>
+                <a:r>
+                  <a:rPr lang="en-US" altLang="ko-KR" sz="2000" dirty="0"/>
+                  <a:t>IDSW</a:t>
+                </a:r>
+                <a:r>
+                  <a:rPr lang="ko-KR" altLang="en-US" sz="2000" dirty="0"/>
+                  <a:t>를 종합한 표준 정확도</a:t>
+                </a:r>
+                <a:r>
+                  <a:rPr lang="en-US" altLang="ko-KR" sz="2000" b="1" dirty="0"/>
+                  <a:t>.</a:t>
+                </a:r>
+                <a:br>
+                  <a:rPr lang="en-US" altLang="ko-KR" sz="2000" b="1" dirty="0"/>
+                </a:br>
+                <a:r>
+                  <a:rPr lang="en-US" altLang="ko-KR" sz="2000" b="1" dirty="0"/>
+                  <a:t>- </a:t>
+                </a:r>
                 <a14:m>
                   <m:oMath xmlns:m="http://schemas.openxmlformats.org/officeDocument/2006/math">
                     <m:r>
                       <m:rPr>
                         <m:sty m:val="p"/>
                       </m:rPr>
-                      <a:rPr lang="en-US" altLang="ko-KR" b="0" i="0" smtClean="0">
+                      <a:rPr lang="en-US" altLang="ko-KR" sz="2000">
                         <a:latin typeface="Cambria Math" panose="02040503050406030204" pitchFamily="18" charset="0"/>
                       </a:rPr>
-                      <m:t>MOTA</m:t>
-                    </m:r>
-                    <m:r>
-                      <a:rPr lang="en-US" altLang="ko-KR" b="0" i="0" smtClean="0">
-                        <a:latin typeface="Cambria Math" panose="02040503050406030204" pitchFamily="18" charset="0"/>
-                      </a:rPr>
-                      <m:t>(</m:t>
+                      <m:t>MOT</m:t>
                     </m:r>
                     <m:r>
                       <m:rPr>
                         <m:sty m:val="p"/>
                       </m:rPr>
-                      <a:rPr lang="en-US" altLang="ko-KR" b="0" i="0" smtClean="0">
+                      <a:rPr lang="en-US" altLang="ko-KR" sz="2000" b="0" i="0" smtClean="0">
                         <a:latin typeface="Cambria Math" panose="02040503050406030204" pitchFamily="18" charset="0"/>
                       </a:rPr>
-                      <m:t>MOT</m:t>
+                      <m:t>A</m:t>
                     </m:r>
                     <m:r>
-                      <a:rPr lang="en-US" altLang="ko-KR" b="0" i="0" smtClean="0">
+                      <a:rPr lang="en-US" altLang="ko-KR" sz="2000">
                         <a:latin typeface="Cambria Math" panose="02040503050406030204" pitchFamily="18" charset="0"/>
                       </a:rPr>
-                      <m:t> </m:t>
-                    </m:r>
-                    <m:r>
-                      <m:rPr>
-                        <m:sty m:val="p"/>
-                      </m:rPr>
-                      <a:rPr lang="en-US" altLang="ko-KR" b="0" i="0" smtClean="0">
-                        <a:latin typeface="Cambria Math" panose="02040503050406030204" pitchFamily="18" charset="0"/>
-                      </a:rPr>
-                      <m:t>accuracy</m:t>
-                    </m:r>
-                    <m:r>
-                      <a:rPr lang="en-US" altLang="ko-KR" b="0" i="0" smtClean="0">
-                        <a:latin typeface="Cambria Math" panose="02040503050406030204" pitchFamily="18" charset="0"/>
-                      </a:rPr>
-                      <m:t>) = 1 − </m:t>
+                      <m:t>= 1 − </m:t>
                     </m:r>
                     <m:f>
                       <m:fPr>
                         <m:ctrlPr>
-                          <a:rPr lang="en-US" altLang="ko-KR" b="0" i="1" smtClean="0">
+                          <a:rPr lang="en-US" altLang="ko-KR" sz="2000" i="1">
                             <a:latin typeface="Cambria Math" panose="02040503050406030204" pitchFamily="18" charset="0"/>
                           </a:rPr>
                         </m:ctrlPr>
@@ -22368,7 +23409,7 @@
                             <m:limLoc m:val="subSup"/>
                             <m:supHide m:val="on"/>
                             <m:ctrlPr>
-                              <a:rPr lang="en-US" altLang="ko-KR" b="0" i="1" smtClean="0">
+                              <a:rPr lang="en-US" altLang="ko-KR" sz="2000" i="1">
                                 <a:latin typeface="Cambria Math" panose="02040503050406030204" pitchFamily="18" charset="0"/>
                               </a:rPr>
                             </m:ctrlPr>
@@ -22379,7 +23420,7 @@
                                 <m:sty m:val="p"/>
                                 <m:brk m:alnAt="9"/>
                               </m:rPr>
-                              <a:rPr lang="en-US" altLang="ko-KR" b="0" i="1" smtClean="0">
+                              <a:rPr lang="en-US" altLang="ko-KR" sz="2000" i="1">
                                 <a:latin typeface="Cambria Math" panose="02040503050406030204" pitchFamily="18" charset="0"/>
                               </a:rPr>
                               <m:t>t</m:t>
@@ -22388,7 +23429,7 @@
                           <m:sup/>
                           <m:e>
                             <m:r>
-                              <a:rPr lang="en-US" altLang="ko-KR" b="0" i="1" smtClean="0">
+                              <a:rPr lang="en-US" altLang="ko-KR" sz="2000" i="1">
                                 <a:latin typeface="Cambria Math" panose="02040503050406030204" pitchFamily="18" charset="0"/>
                               </a:rPr>
                               <m:t>(</m:t>
@@ -22396,7 +23437,7 @@
                             <m:sSub>
                               <m:sSubPr>
                                 <m:ctrlPr>
-                                  <a:rPr lang="en-US" altLang="ko-KR" b="0" i="1" smtClean="0">
+                                  <a:rPr lang="en-US" altLang="ko-KR" sz="2000" i="1">
                                     <a:latin typeface="Cambria Math" panose="02040503050406030204" pitchFamily="18" charset="0"/>
                                   </a:rPr>
                                 </m:ctrlPr>
@@ -22406,7 +23447,7 @@
                                   <m:rPr>
                                     <m:sty m:val="p"/>
                                   </m:rPr>
-                                  <a:rPr lang="en-US" altLang="ko-KR" b="0" i="1" smtClean="0">
+                                  <a:rPr lang="en-US" altLang="ko-KR" sz="2000" i="1">
                                     <a:latin typeface="Cambria Math" panose="02040503050406030204" pitchFamily="18" charset="0"/>
                                   </a:rPr>
                                   <m:t>FN</m:t>
@@ -22417,7 +23458,7 @@
                                   <m:rPr>
                                     <m:sty m:val="p"/>
                                   </m:rPr>
-                                  <a:rPr lang="en-US" altLang="ko-KR" b="0" i="1" smtClean="0">
+                                  <a:rPr lang="en-US" altLang="ko-KR" sz="2000" i="1">
                                     <a:latin typeface="Cambria Math" panose="02040503050406030204" pitchFamily="18" charset="0"/>
                                   </a:rPr>
                                   <m:t>t</m:t>
@@ -22425,7 +23466,7 @@
                               </m:sub>
                             </m:sSub>
                             <m:r>
-                              <a:rPr lang="en-US" altLang="ko-KR" b="0" i="1" smtClean="0">
+                              <a:rPr lang="en-US" altLang="ko-KR" sz="2000" i="1">
                                 <a:latin typeface="Cambria Math" panose="02040503050406030204" pitchFamily="18" charset="0"/>
                               </a:rPr>
                               <m:t> + </m:t>
@@ -22433,7 +23474,7 @@
                             <m:sSub>
                               <m:sSubPr>
                                 <m:ctrlPr>
-                                  <a:rPr lang="en-US" altLang="ko-KR" b="0" i="1" smtClean="0">
+                                  <a:rPr lang="en-US" altLang="ko-KR" sz="2000" i="1">
                                     <a:latin typeface="Cambria Math" panose="02040503050406030204" pitchFamily="18" charset="0"/>
                                   </a:rPr>
                                 </m:ctrlPr>
@@ -22443,7 +23484,7 @@
                                   <m:rPr>
                                     <m:sty m:val="p"/>
                                   </m:rPr>
-                                  <a:rPr lang="en-US" altLang="ko-KR" b="0" i="1" smtClean="0">
+                                  <a:rPr lang="en-US" altLang="ko-KR" sz="2000" i="1">
                                     <a:latin typeface="Cambria Math" panose="02040503050406030204" pitchFamily="18" charset="0"/>
                                   </a:rPr>
                                   <m:t>FP</m:t>
@@ -22454,7 +23495,7 @@
                                   <m:rPr>
                                     <m:sty m:val="p"/>
                                   </m:rPr>
-                                  <a:rPr lang="en-US" altLang="ko-KR" b="0" i="1" smtClean="0">
+                                  <a:rPr lang="en-US" altLang="ko-KR" sz="2000" i="1">
                                     <a:latin typeface="Cambria Math" panose="02040503050406030204" pitchFamily="18" charset="0"/>
                                   </a:rPr>
                                   <m:t>t</m:t>
@@ -22462,7 +23503,7 @@
                               </m:sub>
                             </m:sSub>
                             <m:r>
-                              <a:rPr lang="en-US" altLang="ko-KR" b="0" i="1" smtClean="0">
+                              <a:rPr lang="en-US" altLang="ko-KR" sz="2000" i="1">
                                 <a:latin typeface="Cambria Math" panose="02040503050406030204" pitchFamily="18" charset="0"/>
                               </a:rPr>
                               <m:t> + </m:t>
@@ -22470,7 +23511,7 @@
                             <m:sSub>
                               <m:sSubPr>
                                 <m:ctrlPr>
-                                  <a:rPr lang="en-US" altLang="ko-KR" b="0" i="1" smtClean="0">
+                                  <a:rPr lang="en-US" altLang="ko-KR" sz="2000" i="1">
                                     <a:latin typeface="Cambria Math" panose="02040503050406030204" pitchFamily="18" charset="0"/>
                                   </a:rPr>
                                 </m:ctrlPr>
@@ -22480,7 +23521,7 @@
                                   <m:rPr>
                                     <m:sty m:val="p"/>
                                   </m:rPr>
-                                  <a:rPr lang="en-US" altLang="ko-KR" b="0" i="1" smtClean="0">
+                                  <a:rPr lang="en-US" altLang="ko-KR" sz="2000" i="1">
                                     <a:latin typeface="Cambria Math" panose="02040503050406030204" pitchFamily="18" charset="0"/>
                                   </a:rPr>
                                   <m:t>IDSW</m:t>
@@ -22491,7 +23532,7 @@
                                   <m:rPr>
                                     <m:sty m:val="p"/>
                                   </m:rPr>
-                                  <a:rPr lang="en-US" altLang="ko-KR" b="0" i="1" smtClean="0">
+                                  <a:rPr lang="en-US" altLang="ko-KR" sz="2000" i="1">
                                     <a:latin typeface="Cambria Math" panose="02040503050406030204" pitchFamily="18" charset="0"/>
                                   </a:rPr>
                                   <m:t>t</m:t>
@@ -22499,7 +23540,7 @@
                               </m:sub>
                             </m:sSub>
                             <m:r>
-                              <a:rPr lang="en-US" altLang="ko-KR" b="0" i="1" smtClean="0">
+                              <a:rPr lang="en-US" altLang="ko-KR" sz="2000" i="1">
                                 <a:latin typeface="Cambria Math" panose="02040503050406030204" pitchFamily="18" charset="0"/>
                               </a:rPr>
                               <m:t>)</m:t>
@@ -22513,7 +23554,7 @@
                             <m:chr m:val="∑"/>
                             <m:supHide m:val="on"/>
                             <m:ctrlPr>
-                              <a:rPr lang="en-US" altLang="ko-KR" b="0" i="1" smtClean="0">
+                              <a:rPr lang="en-US" altLang="ko-KR" sz="2000" i="1">
                                 <a:latin typeface="Cambria Math" panose="02040503050406030204" pitchFamily="18" charset="0"/>
                               </a:rPr>
                             </m:ctrlPr>
@@ -22524,7 +23565,7 @@
                                 <m:sty m:val="p"/>
                                 <m:brk m:alnAt="7"/>
                               </m:rPr>
-                              <a:rPr lang="en-US" altLang="ko-KR" b="0" i="1" smtClean="0">
+                              <a:rPr lang="en-US" altLang="ko-KR" sz="2000" i="1">
                                 <a:latin typeface="Cambria Math" panose="02040503050406030204" pitchFamily="18" charset="0"/>
                               </a:rPr>
                               <m:t>t</m:t>
@@ -22535,7 +23576,7 @@
                             <m:sSup>
                               <m:sSupPr>
                                 <m:ctrlPr>
-                                  <a:rPr lang="en-US" altLang="ko-KR" b="0" i="1" smtClean="0">
+                                  <a:rPr lang="en-US" altLang="ko-KR" sz="2000" i="1">
                                     <a:latin typeface="Cambria Math" panose="02040503050406030204" pitchFamily="18" charset="0"/>
                                   </a:rPr>
                                 </m:ctrlPr>
@@ -22545,7 +23586,7 @@
                                   <m:rPr>
                                     <m:sty m:val="p"/>
                                   </m:rPr>
-                                  <a:rPr lang="en-US" altLang="ko-KR" b="0" i="1" smtClean="0">
+                                  <a:rPr lang="en-US" altLang="ko-KR" sz="2000" i="1">
                                     <a:latin typeface="Cambria Math" panose="02040503050406030204" pitchFamily="18" charset="0"/>
                                   </a:rPr>
                                   <m:t>GT</m:t>
@@ -22556,7 +23597,7 @@
                                   <m:rPr>
                                     <m:sty m:val="p"/>
                                   </m:rPr>
-                                  <a:rPr lang="en-US" altLang="ko-KR" b="0" i="1" smtClean="0">
+                                  <a:rPr lang="en-US" altLang="ko-KR" sz="2000" i="1">
                                     <a:latin typeface="Cambria Math" panose="02040503050406030204" pitchFamily="18" charset="0"/>
                                   </a:rPr>
                                   <m:t>t</m:t>
@@ -22568,7 +23609,7 @@
                       </m:den>
                     </m:f>
                     <m:r>
-                      <a:rPr lang="en-US" altLang="ko-KR" b="0" i="1" smtClean="0">
+                      <a:rPr lang="en-US" altLang="ko-KR" sz="2000" i="1">
                         <a:latin typeface="Cambria Math" panose="02040503050406030204" pitchFamily="18" charset="0"/>
                       </a:rPr>
                       <m:t>.</m:t>
@@ -22576,7 +23617,7 @@
                   </m:oMath>
                 </a14:m>
                 <a:r>
-                  <a:rPr lang="en-US" altLang="ko-KR" dirty="0"/>
+                  <a:rPr lang="en-US" altLang="ko-KR" sz="2000" dirty="0"/>
                   <a:t> </a:t>
                 </a:r>
               </a:p>
@@ -22585,50 +23626,7 @@
                   <a:buFont typeface="Arial" panose="020B0604020202020204" pitchFamily="34" charset="0"/>
                   <a:buChar char="•"/>
                 </a:pPr>
-                <a:r>
-                  <a:rPr lang="ko-KR" altLang="en-US" dirty="0"/>
-                  <a:t>표</a:t>
-                </a:r>
-                <a:r>
-                  <a:rPr lang="en-US" altLang="ko-KR" dirty="0"/>
-                  <a:t>2</a:t>
-                </a:r>
-                <a:r>
-                  <a:rPr lang="ko-KR" altLang="en-US" dirty="0"/>
-                  <a:t>는 </a:t>
-                </a:r>
-                <a:r>
-                  <a:rPr lang="en-US" altLang="ko-KR" dirty="0"/>
-                  <a:t>KITTI test set </a:t>
-                </a:r>
-                <a:r>
-                  <a:rPr lang="ko-KR" altLang="en-US" dirty="0" err="1"/>
-                  <a:t>에대한</a:t>
-                </a:r>
-                <a:r>
-                  <a:rPr lang="ko-KR" altLang="en-US" dirty="0"/>
-                  <a:t> </a:t>
-                </a:r>
-                <a:r>
-                  <a:rPr lang="en-US" altLang="ko-KR" dirty="0"/>
-                  <a:t>MOTA </a:t>
-                </a:r>
-                <a:r>
-                  <a:rPr lang="ko-KR" altLang="en-US" dirty="0"/>
-                  <a:t>결과표로 </a:t>
-                </a:r>
-                <a:r>
-                  <a:rPr lang="en-US" altLang="ko-KR" dirty="0"/>
-                  <a:t>90%</a:t>
-                </a:r>
-                <a:r>
-                  <a:rPr lang="ko-KR" altLang="en-US" dirty="0"/>
-                  <a:t>대의 결과를 보여줌</a:t>
-                </a:r>
-                <a:r>
-                  <a:rPr lang="en-US" altLang="ko-KR" dirty="0"/>
-                  <a:t>[5].</a:t>
-                </a:r>
+                <a:endParaRPr lang="en-US" altLang="ko-KR" sz="2000" b="1" dirty="0"/>
               </a:p>
               <a:p>
                 <a:pPr marL="285750" indent="-285750">
@@ -22636,21 +23634,37 @@
                   <a:buChar char="•"/>
                 </a:pPr>
                 <a:r>
-                  <a:rPr lang="ko-KR" altLang="en-US" dirty="0"/>
-                  <a:t>제안하는 기법은 정적인 수신부임에 따라 보다 높은 </a:t>
+                  <a:rPr lang="en-US" altLang="ko-KR" sz="2000" b="1" dirty="0" err="1"/>
+                  <a:t>AssA</a:t>
                 </a:r>
                 <a:r>
-                  <a:rPr lang="en-US" altLang="ko-KR" dirty="0"/>
-                  <a:t>MOTA </a:t>
+                  <a:rPr lang="en-US" altLang="ko-KR" sz="2000" b="1" dirty="0"/>
+                  <a:t>(Association Accuracy)</a:t>
+                </a:r>
+                <a:br>
+                  <a:rPr lang="en-US" altLang="ko-KR" sz="2000" b="1" dirty="0"/>
+                </a:br>
+                <a:r>
+                  <a:rPr lang="en-US" altLang="ko-KR" sz="2000" b="1" dirty="0"/>
+                  <a:t>- </a:t>
                 </a:r>
                 <a:r>
-                  <a:rPr lang="ko-KR" altLang="en-US" dirty="0"/>
-                  <a:t>기록</a:t>
+                  <a:rPr lang="ko-KR" altLang="en-US" sz="2000" dirty="0"/>
+                  <a:t>올바른 </a:t>
                 </a:r>
                 <a:r>
-                  <a:rPr lang="en-US" altLang="ko-KR" dirty="0"/>
+                  <a:rPr lang="en-US" altLang="ko-KR" sz="2000" dirty="0"/>
+                  <a:t>ID</a:t>
+                </a:r>
+                <a:r>
+                  <a:rPr lang="ko-KR" altLang="en-US" sz="2000" dirty="0"/>
+                  <a:t>가 유지된 시간 비율의 가중평균</a:t>
+                </a:r>
+                <a:r>
+                  <a:rPr lang="en-US" altLang="ko-KR" sz="2000" dirty="0"/>
                   <a:t>.</a:t>
                 </a:r>
+                <a:endParaRPr lang="en-US" altLang="ko-KR" sz="1000" dirty="0"/>
               </a:p>
             </p:txBody>
           </p:sp>
@@ -22658,10 +23672,10 @@
         <mc:Fallback>
           <p:sp>
             <p:nvSpPr>
-              <p:cNvPr id="4" name="TextBox 3">
+              <p:cNvPr id="7" name="TextBox 6">
                 <a:extLst>
                   <a:ext uri="{FF2B5EF4-FFF2-40B4-BE49-F238E27FC236}">
-                    <a16:creationId xmlns:a16="http://schemas.microsoft.com/office/drawing/2014/main" id="{4131AD9A-0C01-EF4A-EC54-56F0CDCAB555}"/>
+                    <a16:creationId xmlns:a16="http://schemas.microsoft.com/office/drawing/2014/main" id="{CB7D23DC-E6AC-6A9E-6D7E-04667438039F}"/>
                   </a:ext>
                 </a:extLst>
               </p:cNvPr>
@@ -22672,8 +23686,8 @@
             </p:nvSpPr>
             <p:spPr>
               <a:xfrm>
-                <a:off x="305274" y="4061895"/>
-                <a:ext cx="8019576" cy="1382366"/>
+                <a:off x="369115" y="1442335"/>
+                <a:ext cx="11563241" cy="3988143"/>
               </a:xfrm>
               <a:prstGeom prst="rect">
                 <a:avLst/>
@@ -22681,7 +23695,7 @@
               <a:blipFill>
                 <a:blip r:embed="rId3"/>
                 <a:stretch>
-                  <a:fillRect l="-456" t="-2203" b="-5727"/>
+                  <a:fillRect l="-475" t="-917" b="-1835"/>
                 </a:stretch>
               </a:blipFill>
             </p:spPr>
@@ -22704,7 +23718,7 @@
         <mc:Choice xmlns:a14="http://schemas.microsoft.com/office/drawing/2010/main" Requires="a14">
           <p:sp>
             <p:nvSpPr>
-              <p:cNvPr id="5" name="TextBox 4">
+              <p:cNvPr id="8" name="TextBox 7">
                 <a:extLst>
                   <a:ext uri="{FF2B5EF4-FFF2-40B4-BE49-F238E27FC236}">
                     <a16:creationId xmlns:a16="http://schemas.microsoft.com/office/drawing/2014/main" id="{16F4F592-0963-1ED0-BE5F-A3F52593EA81}"/>
@@ -22716,7 +23730,7 @@
             </p:nvSpPr>
             <p:spPr>
               <a:xfrm>
-                <a:off x="8089827" y="4061895"/>
+                <a:off x="6096000" y="3506221"/>
                 <a:ext cx="4336868" cy="1777987"/>
               </a:xfrm>
               <a:prstGeom prst="rect">
@@ -23055,7 +24069,7 @@
         <mc:Fallback>
           <p:sp>
             <p:nvSpPr>
-              <p:cNvPr id="5" name="TextBox 4">
+              <p:cNvPr id="8" name="TextBox 7">
                 <a:extLst>
                   <a:ext uri="{FF2B5EF4-FFF2-40B4-BE49-F238E27FC236}">
                     <a16:creationId xmlns:a16="http://schemas.microsoft.com/office/drawing/2014/main" id="{16F4F592-0963-1ED0-BE5F-A3F52593EA81}"/>
@@ -23069,7 +24083,7 @@
             </p:nvSpPr>
             <p:spPr>
               <a:xfrm>
-                <a:off x="8089827" y="4061895"/>
+                <a:off x="6096000" y="3506221"/>
                 <a:ext cx="4336868" cy="1777987"/>
               </a:xfrm>
               <a:prstGeom prst="rect">
@@ -23097,379 +24111,10 @@
           </p:sp>
         </mc:Fallback>
       </mc:AlternateContent>
-      <p:sp>
-        <p:nvSpPr>
-          <p:cNvPr id="6" name="TextBox 5">
-            <a:extLst>
-              <a:ext uri="{FF2B5EF4-FFF2-40B4-BE49-F238E27FC236}">
-                <a16:creationId xmlns:a16="http://schemas.microsoft.com/office/drawing/2014/main" id="{3EA11118-CCC7-ABBD-51EE-5594F8FA5484}"/>
-              </a:ext>
-            </a:extLst>
-          </p:cNvPr>
-          <p:cNvSpPr txBox="1"/>
-          <p:nvPr/>
-        </p:nvSpPr>
-        <p:spPr>
-          <a:xfrm>
-            <a:off x="2275491" y="1266129"/>
-            <a:ext cx="1600200" cy="369332"/>
-          </a:xfrm>
-          <a:prstGeom prst="rect">
-            <a:avLst/>
-          </a:prstGeom>
-        </p:spPr>
-        <p:txBody>
-          <a:bodyPr wrap="square" rtlCol="0">
-            <a:spAutoFit/>
-          </a:bodyPr>
-          <a:lstStyle/>
-          <a:p>
-            <a:r>
-              <a:rPr lang="ko-KR" altLang="en-US" b="1" dirty="0"/>
-              <a:t>표</a:t>
-            </a:r>
-            <a:r>
-              <a:rPr lang="en-US" altLang="ko-KR" b="1" dirty="0"/>
-              <a:t>1. </a:t>
-            </a:r>
-            <a:r>
-              <a:rPr lang="ko-KR" altLang="en-US" b="1" dirty="0"/>
-              <a:t>검증결과</a:t>
-            </a:r>
-          </a:p>
-        </p:txBody>
-      </p:sp>
-      <p:graphicFrame>
-        <p:nvGraphicFramePr>
-          <p:cNvPr id="7" name="표 6">
-            <a:extLst>
-              <a:ext uri="{FF2B5EF4-FFF2-40B4-BE49-F238E27FC236}">
-                <a16:creationId xmlns:a16="http://schemas.microsoft.com/office/drawing/2014/main" id="{493B0232-B7F7-A70A-DC52-207F3E2A11B6}"/>
-              </a:ext>
-            </a:extLst>
-          </p:cNvPr>
-          <p:cNvGraphicFramePr>
-            <a:graphicFrameLocks noGrp="1"/>
-          </p:cNvGraphicFramePr>
-          <p:nvPr>
-            <p:extLst>
-              <p:ext uri="{D42A27DB-BD31-4B8C-83A1-F6EECF244321}">
-                <p14:modId xmlns:p14="http://schemas.microsoft.com/office/powerpoint/2010/main" val="1774048401"/>
-              </p:ext>
-            </p:extLst>
-          </p:nvPr>
-        </p:nvGraphicFramePr>
-        <p:xfrm>
-          <a:off x="6343905" y="1658833"/>
-          <a:ext cx="5739890" cy="1837374"/>
-        </p:xfrm>
-        <a:graphic>
-          <a:graphicData uri="http://schemas.openxmlformats.org/drawingml/2006/table">
-            <a:tbl>
-              <a:tblPr firstRow="1" bandRow="1">
-                <a:tableStyleId>{5C22544A-7EE6-4342-B048-85BDC9FD1C3A}</a:tableStyleId>
-              </a:tblPr>
-              <a:tblGrid>
-                <a:gridCol w="4226135">
-                  <a:extLst>
-                    <a:ext uri="{9D8B030D-6E8A-4147-A177-3AD203B41FA5}">
-                      <a16:colId xmlns:a16="http://schemas.microsoft.com/office/drawing/2014/main" val="1248245821"/>
-                    </a:ext>
-                  </a:extLst>
-                </a:gridCol>
-                <a:gridCol w="1513755">
-                  <a:extLst>
-                    <a:ext uri="{9D8B030D-6E8A-4147-A177-3AD203B41FA5}">
-                      <a16:colId xmlns:a16="http://schemas.microsoft.com/office/drawing/2014/main" val="1363305588"/>
-                    </a:ext>
-                  </a:extLst>
-                </a:gridCol>
-              </a:tblGrid>
-              <a:tr h="306229">
-                <a:tc>
-                  <a:txBody>
-                    <a:bodyPr/>
-                    <a:lstStyle/>
-                    <a:p>
-                      <a:pPr algn="ctr" latinLnBrk="1"/>
-                      <a:r>
-                        <a:rPr lang="ko-KR" altLang="en-US" sz="1300" dirty="0"/>
-                        <a:t>기법</a:t>
-                      </a:r>
-                    </a:p>
-                  </a:txBody>
-                  <a:tcPr/>
-                </a:tc>
-                <a:tc>
-                  <a:txBody>
-                    <a:bodyPr/>
-                    <a:lstStyle/>
-                    <a:p>
-                      <a:pPr algn="ctr" latinLnBrk="1"/>
-                      <a:r>
-                        <a:rPr lang="en-US" altLang="ko-KR" sz="1300" dirty="0"/>
-                        <a:t>MOTA</a:t>
-                      </a:r>
-                      <a:endParaRPr lang="ko-KR" altLang="en-US" sz="1300" dirty="0"/>
-                    </a:p>
-                  </a:txBody>
-                  <a:tcPr/>
-                </a:tc>
-                <a:extLst>
-                  <a:ext uri="{0D108BD9-81ED-4DB2-BD59-A6C34878D82A}">
-                    <a16:rowId xmlns:a16="http://schemas.microsoft.com/office/drawing/2014/main" val="1437392871"/>
-                  </a:ext>
-                </a:extLst>
-              </a:tr>
-              <a:tr h="306229">
-                <a:tc>
-                  <a:txBody>
-                    <a:bodyPr/>
-                    <a:lstStyle/>
-                    <a:p>
-                      <a:pPr algn="ctr" latinLnBrk="1"/>
-                      <a:r>
-                        <a:rPr lang="en-US" altLang="ko-KR" sz="1300" b="0" dirty="0" err="1"/>
-                        <a:t>MCTrack</a:t>
-                      </a:r>
-                      <a:endParaRPr lang="ko-KR" altLang="en-US" sz="1300" b="0" dirty="0"/>
-                    </a:p>
-                  </a:txBody>
-                  <a:tcPr/>
-                </a:tc>
-                <a:tc>
-                  <a:txBody>
-                    <a:bodyPr/>
-                    <a:lstStyle/>
-                    <a:p>
-                      <a:pPr algn="ctr" latinLnBrk="1"/>
-                      <a:r>
-                        <a:rPr lang="en-US" altLang="ko-KR" sz="1300" b="0" dirty="0"/>
-                        <a:t>91.62%</a:t>
-                      </a:r>
-                      <a:endParaRPr lang="ko-KR" altLang="en-US" sz="1300" b="0" dirty="0"/>
-                    </a:p>
-                  </a:txBody>
-                  <a:tcPr/>
-                </a:tc>
-                <a:extLst>
-                  <a:ext uri="{0D108BD9-81ED-4DB2-BD59-A6C34878D82A}">
-                    <a16:rowId xmlns:a16="http://schemas.microsoft.com/office/drawing/2014/main" val="3017696609"/>
-                  </a:ext>
-                </a:extLst>
-              </a:tr>
-              <a:tr h="306229">
-                <a:tc>
-                  <a:txBody>
-                    <a:bodyPr/>
-                    <a:lstStyle/>
-                    <a:p>
-                      <a:pPr algn="ctr" latinLnBrk="1"/>
-                      <a:r>
-                        <a:rPr lang="en-US" altLang="ko-KR" sz="1300" b="0" dirty="0" err="1"/>
-                        <a:t>CasTrack</a:t>
-                      </a:r>
-                      <a:endParaRPr lang="ko-KR" altLang="en-US" sz="1300" b="0" dirty="0"/>
-                    </a:p>
-                  </a:txBody>
-                  <a:tcPr/>
-                </a:tc>
-                <a:tc>
-                  <a:txBody>
-                    <a:bodyPr/>
-                    <a:lstStyle/>
-                    <a:p>
-                      <a:pPr algn="ctr" latinLnBrk="1"/>
-                      <a:r>
-                        <a:rPr lang="en-US" altLang="ko-KR" sz="1300" b="0" dirty="0"/>
-                        <a:t>91.91%</a:t>
-                      </a:r>
-                      <a:endParaRPr lang="ko-KR" altLang="en-US" sz="1300" b="0" dirty="0"/>
-                    </a:p>
-                  </a:txBody>
-                  <a:tcPr/>
-                </a:tc>
-                <a:extLst>
-                  <a:ext uri="{0D108BD9-81ED-4DB2-BD59-A6C34878D82A}">
-                    <a16:rowId xmlns:a16="http://schemas.microsoft.com/office/drawing/2014/main" val="1383321197"/>
-                  </a:ext>
-                </a:extLst>
-              </a:tr>
-              <a:tr h="306229">
-                <a:tc>
-                  <a:txBody>
-                    <a:bodyPr/>
-                    <a:lstStyle/>
-                    <a:p>
-                      <a:pPr algn="ctr" latinLnBrk="1"/>
-                      <a:r>
-                        <a:rPr lang="en-US" altLang="ko-KR" sz="1300" b="0" dirty="0"/>
-                        <a:t>RAM</a:t>
-                      </a:r>
-                      <a:endParaRPr lang="ko-KR" altLang="en-US" sz="1300" b="0" dirty="0"/>
-                    </a:p>
-                  </a:txBody>
-                  <a:tcPr/>
-                </a:tc>
-                <a:tc>
-                  <a:txBody>
-                    <a:bodyPr/>
-                    <a:lstStyle/>
-                    <a:p>
-                      <a:pPr algn="ctr" latinLnBrk="1"/>
-                      <a:r>
-                        <a:rPr lang="en-US" altLang="ko-KR" sz="1300" b="0" dirty="0"/>
-                        <a:t>91.61%</a:t>
-                      </a:r>
-                      <a:endParaRPr lang="ko-KR" altLang="en-US" sz="1300" b="0" dirty="0"/>
-                    </a:p>
-                  </a:txBody>
-                  <a:tcPr/>
-                </a:tc>
-                <a:extLst>
-                  <a:ext uri="{0D108BD9-81ED-4DB2-BD59-A6C34878D82A}">
-                    <a16:rowId xmlns:a16="http://schemas.microsoft.com/office/drawing/2014/main" val="1045870170"/>
-                  </a:ext>
-                </a:extLst>
-              </a:tr>
-              <a:tr h="306229">
-                <a:tc>
-                  <a:txBody>
-                    <a:bodyPr/>
-                    <a:lstStyle/>
-                    <a:p>
-                      <a:pPr algn="ctr" latinLnBrk="1"/>
-                      <a:r>
-                        <a:rPr lang="en-US" altLang="ko-KR" sz="1300" b="0" dirty="0"/>
-                        <a:t>OC-SORT</a:t>
-                      </a:r>
-                      <a:endParaRPr lang="ko-KR" altLang="en-US" sz="1300" b="0" dirty="0"/>
-                    </a:p>
-                  </a:txBody>
-                  <a:tcPr/>
-                </a:tc>
-                <a:tc>
-                  <a:txBody>
-                    <a:bodyPr/>
-                    <a:lstStyle/>
-                    <a:p>
-                      <a:pPr algn="ctr" latinLnBrk="1"/>
-                      <a:r>
-                        <a:rPr lang="en-US" altLang="ko-KR" sz="1300" b="0" dirty="0"/>
-                        <a:t>90.28%</a:t>
-                      </a:r>
-                      <a:endParaRPr lang="ko-KR" altLang="en-US" sz="1300" b="0" dirty="0"/>
-                    </a:p>
-                  </a:txBody>
-                  <a:tcPr/>
-                </a:tc>
-                <a:extLst>
-                  <a:ext uri="{0D108BD9-81ED-4DB2-BD59-A6C34878D82A}">
-                    <a16:rowId xmlns:a16="http://schemas.microsoft.com/office/drawing/2014/main" val="133207077"/>
-                  </a:ext>
-                </a:extLst>
-              </a:tr>
-              <a:tr h="306229">
-                <a:tc>
-                  <a:txBody>
-                    <a:bodyPr/>
-                    <a:lstStyle/>
-                    <a:p>
-                      <a:pPr algn="ctr" latinLnBrk="1"/>
-                      <a:r>
-                        <a:rPr lang="en-US" altLang="ko-KR" sz="1300" b="0" dirty="0" err="1"/>
-                        <a:t>BiTrack</a:t>
-                      </a:r>
-                      <a:endParaRPr lang="ko-KR" altLang="en-US" sz="1300" b="0" dirty="0"/>
-                    </a:p>
-                  </a:txBody>
-                  <a:tcPr/>
-                </a:tc>
-                <a:tc>
-                  <a:txBody>
-                    <a:bodyPr/>
-                    <a:lstStyle/>
-                    <a:p>
-                      <a:pPr algn="ctr" latinLnBrk="1"/>
-                      <a:r>
-                        <a:rPr lang="en-US" altLang="ko-KR" sz="1300" b="0" dirty="0"/>
-                        <a:t>91.52%</a:t>
-                      </a:r>
-                      <a:endParaRPr lang="ko-KR" altLang="en-US" sz="1300" b="0" dirty="0"/>
-                    </a:p>
-                  </a:txBody>
-                  <a:tcPr/>
-                </a:tc>
-                <a:extLst>
-                  <a:ext uri="{0D108BD9-81ED-4DB2-BD59-A6C34878D82A}">
-                    <a16:rowId xmlns:a16="http://schemas.microsoft.com/office/drawing/2014/main" val="1531617306"/>
-                  </a:ext>
-                </a:extLst>
-              </a:tr>
-            </a:tbl>
-          </a:graphicData>
-        </a:graphic>
-      </p:graphicFrame>
-      <p:sp>
-        <p:nvSpPr>
-          <p:cNvPr id="8" name="TextBox 7">
-            <a:extLst>
-              <a:ext uri="{FF2B5EF4-FFF2-40B4-BE49-F238E27FC236}">
-                <a16:creationId xmlns:a16="http://schemas.microsoft.com/office/drawing/2014/main" id="{0569836F-0DD1-A057-1FBD-AE5B82E0F968}"/>
-              </a:ext>
-            </a:extLst>
-          </p:cNvPr>
-          <p:cNvSpPr txBox="1"/>
-          <p:nvPr/>
-        </p:nvSpPr>
-        <p:spPr>
-          <a:xfrm>
-            <a:off x="7848874" y="1271074"/>
-            <a:ext cx="2755352" cy="369332"/>
-          </a:xfrm>
-          <a:prstGeom prst="rect">
-            <a:avLst/>
-          </a:prstGeom>
-        </p:spPr>
-        <p:txBody>
-          <a:bodyPr wrap="square" rtlCol="0">
-            <a:spAutoFit/>
-          </a:bodyPr>
-          <a:lstStyle/>
-          <a:p>
-            <a:pPr algn="ctr"/>
-            <a:r>
-              <a:rPr lang="ko-KR" altLang="en-US" b="1" dirty="0"/>
-              <a:t>표</a:t>
-            </a:r>
-            <a:r>
-              <a:rPr lang="en-US" altLang="ko-KR" b="1" dirty="0"/>
-              <a:t>2. </a:t>
-            </a:r>
-            <a:r>
-              <a:rPr lang="ko-KR" altLang="en-US" b="1" dirty="0"/>
-              <a:t>타 </a:t>
-            </a:r>
-            <a:r>
-              <a:rPr lang="en-US" altLang="ko-KR" b="1" dirty="0"/>
-              <a:t>Method</a:t>
-            </a:r>
-            <a:r>
-              <a:rPr lang="ko-KR" altLang="en-US" b="1" dirty="0"/>
-              <a:t> </a:t>
-            </a:r>
-            <a:r>
-              <a:rPr lang="en-US" altLang="ko-KR" b="1" dirty="0"/>
-              <a:t>MOTA</a:t>
-            </a:r>
-            <a:endParaRPr lang="ko-KR" altLang="en-US" b="1" dirty="0"/>
-          </a:p>
-        </p:txBody>
-      </p:sp>
     </p:spTree>
     <p:extLst>
       <p:ext uri="{BB962C8B-B14F-4D97-AF65-F5344CB8AC3E}">
-        <p14:creationId xmlns:p14="http://schemas.microsoft.com/office/powerpoint/2010/main" val="3387734341"/>
+        <p14:creationId xmlns:p14="http://schemas.microsoft.com/office/powerpoint/2010/main" val="3736335654"/>
       </p:ext>
     </p:extLst>
   </p:cSld>

</xml_diff>